<commit_message>
fix: D87 amended — poster template at 34 x 22.5 in with abstract, methods, conclusions, limitations, references, acknowledgments sections and author photo
Co-Authored-By: Claude Opus 5.5 <noreply@anthropic.com>
</commit_message>
<xml_diff>
--- a/project/poster/honr464_poster_template.pptx
+++ b/project/poster/honr464_poster_template.pptx
@@ -8,7 +8,7 @@
     <p:sldId id="256" r:id="rId7"/>
     <p:sldId id="257" r:id="rId8"/>
   </p:sldIdLst>
-  <p:sldSz cx="43891200" cy="32918400" type="screen4x3"/>
+  <p:sldSz cx="31089600" cy="20574000" type="screen4x3"/>
   <p:notesSz cx="6858000" cy="9144000"/>
   <p:defaultTextStyle>
     <a:defPPr>
@@ -3097,8 +3097,8 @@
         </p:nvSpPr>
         <p:spPr>
           <a:xfrm>
-            <a:off x="0" y="6995160"/>
-            <a:ext cx="12915900" cy="25923240"/>
+            <a:off x="0" y="4434840"/>
+            <a:ext cx="7909559" cy="16139159"/>
           </a:xfrm>
           <a:prstGeom prst="rect">
             <a:avLst/>
@@ -3141,8 +3141,8 @@
         </p:nvSpPr>
         <p:spPr>
           <a:xfrm>
-            <a:off x="30975300" y="6995160"/>
-            <a:ext cx="12915900" cy="25923240"/>
+            <a:off x="23180039" y="4434840"/>
+            <a:ext cx="7909560" cy="16139159"/>
           </a:xfrm>
           <a:prstGeom prst="rect">
             <a:avLst/>
@@ -3177,112 +3177,9 @@
           </a:p>
         </p:txBody>
       </p:sp>
-      <p:sp>
-        <p:nvSpPr>
-          <p:cNvPr id="4" name="Title"/>
-          <p:cNvSpPr txBox="1"/>
-          <p:nvPr/>
-        </p:nvSpPr>
-        <p:spPr>
-          <a:xfrm>
-            <a:off x="685800" y="320040"/>
-            <a:ext cx="28803600" cy="2331720"/>
-          </a:xfrm>
-          <a:prstGeom prst="rect">
-            <a:avLst/>
-          </a:prstGeom>
-          <a:noFill/>
-        </p:spPr>
-        <p:txBody>
-          <a:bodyPr wrap="square" anchor="t" lIns="109728" rIns="109728" tIns="109728" bIns="109728">
-            <a:noAutofit/>
-          </a:bodyPr>
-          <a:lstStyle/>
-          <a:p>
-            <a:pPr algn="l">
-              <a:spcAft>
-                <a:spcPts val="0"/>
-              </a:spcAft>
-            </a:pPr>
-            <a:r>
-              <a:rPr sz="7200" b="1" i="0">
-                <a:solidFill>
-                  <a:srgbClr val="000000"/>
-                </a:solidFill>
-                <a:latin typeface="Arial"/>
-              </a:rPr>
-              <a:t>Title: your research problem and its answer</a:t>
-            </a:r>
-          </a:p>
-        </p:txBody>
-      </p:sp>
-      <p:sp>
-        <p:nvSpPr>
-          <p:cNvPr id="5" name="Authors and affiliations"/>
-          <p:cNvSpPr txBox="1"/>
-          <p:nvPr/>
-        </p:nvSpPr>
-        <p:spPr>
-          <a:xfrm>
-            <a:off x="685800" y="2697480"/>
-            <a:ext cx="28803600" cy="1371600"/>
-          </a:xfrm>
-          <a:prstGeom prst="rect">
-            <a:avLst/>
-          </a:prstGeom>
-          <a:noFill/>
-        </p:spPr>
-        <p:txBody>
-          <a:bodyPr wrap="square" anchor="t" lIns="109728" rIns="109728" tIns="109728" bIns="109728">
-            <a:noAutofit/>
-          </a:bodyPr>
-          <a:lstStyle/>
-          <a:p>
-            <a:pPr algn="l">
-              <a:spcAft>
-                <a:spcPts val="1000"/>
-              </a:spcAft>
-            </a:pPr>
-            <a:r>
-              <a:rPr sz="3600" b="1" i="0">
-                <a:solidFill>
-                  <a:srgbClr val="000000"/>
-                </a:solidFill>
-                <a:latin typeface="Arial"/>
-              </a:rPr>
-              <a:t>Your Name</a:t>
-            </a:r>
-            <a:r>
-              <a:rPr sz="3200" b="0" i="0">
-                <a:solidFill>
-                  <a:srgbClr val="000000"/>
-                </a:solidFill>
-                <a:latin typeface="Arial"/>
-              </a:rPr>
-              <a:t>  ·  Your major, Your college  ·  John Martinson Honors College, Purdue University</a:t>
-            </a:r>
-          </a:p>
-          <a:p>
-            <a:pPr algn="l">
-              <a:spcAft>
-                <a:spcPts val="1000"/>
-              </a:spcAft>
-            </a:pPr>
-            <a:r>
-              <a:rPr sz="2800" b="0" i="0">
-                <a:solidFill>
-                  <a:srgbClr val="404040"/>
-                </a:solidFill>
-                <a:latin typeface="Arial"/>
-              </a:rPr>
-              <a:t>Faculty mentor: Professor Davi Moreira, Mitch Daniels School of Business  ·  your.email@purdue.edu</a:t>
-            </a:r>
-          </a:p>
-        </p:txBody>
-      </p:sp>
       <p:pic>
         <p:nvPicPr>
-          <p:cNvPr id="6" name="Purdue University mark" descr="Purdue University"/>
+          <p:cNvPr id="4" name="Author photo (replace with yours; optional)" descr="Author photo"/>
           <p:cNvPicPr>
             <a:picLocks noChangeAspect="1"/>
           </p:cNvPicPr>
@@ -3290,6 +3187,157 @@
         </p:nvPicPr>
         <p:blipFill>
           <a:blip r:embed="rId2"/>
+          <a:stretch>
+            <a:fillRect/>
+          </a:stretch>
+        </p:blipFill>
+        <p:spPr>
+          <a:xfrm>
+            <a:off x="457200" y="320040"/>
+            <a:ext cx="1920240" cy="1920240"/>
+          </a:xfrm>
+          <a:prstGeom prst="rect">
+            <a:avLst/>
+          </a:prstGeom>
+        </p:spPr>
+      </p:pic>
+      <p:pic>
+        <p:nvPicPr>
+          <p:cNvPr id="5" name="LinkedIn icon (optional)" descr="image.png"/>
+          <p:cNvPicPr>
+            <a:picLocks noChangeAspect="1"/>
+          </p:cNvPicPr>
+          <p:nvPr/>
+        </p:nvPicPr>
+        <p:blipFill>
+          <a:blip r:embed="rId3"/>
+          <a:stretch>
+            <a:fillRect/>
+          </a:stretch>
+        </p:blipFill>
+        <p:spPr>
+          <a:xfrm>
+            <a:off x="1965960" y="1783080"/>
+            <a:ext cx="457200" cy="457200"/>
+          </a:xfrm>
+          <a:prstGeom prst="rect">
+            <a:avLst/>
+          </a:prstGeom>
+        </p:spPr>
+      </p:pic>
+      <p:sp>
+        <p:nvSpPr>
+          <p:cNvPr id="6" name="Title"/>
+          <p:cNvSpPr txBox="1"/>
+          <p:nvPr/>
+        </p:nvSpPr>
+        <p:spPr>
+          <a:xfrm>
+            <a:off x="2651760" y="228600"/>
+            <a:ext cx="19202400" cy="1417320"/>
+          </a:xfrm>
+          <a:prstGeom prst="rect">
+            <a:avLst/>
+          </a:prstGeom>
+          <a:noFill/>
+        </p:spPr>
+        <p:txBody>
+          <a:bodyPr wrap="square" anchor="t" lIns="109728" rIns="109728" tIns="109728" bIns="109728">
+            <a:noAutofit/>
+          </a:bodyPr>
+          <a:lstStyle/>
+          <a:p>
+            <a:pPr algn="l">
+              <a:spcAft>
+                <a:spcPts val="0"/>
+              </a:spcAft>
+            </a:pPr>
+            <a:r>
+              <a:rPr sz="5400" b="1" i="0">
+                <a:solidFill>
+                  <a:srgbClr val="000000"/>
+                </a:solidFill>
+                <a:latin typeface="Arial"/>
+              </a:rPr>
+              <a:t>Title: your research problem and its answer</a:t>
+            </a:r>
+          </a:p>
+        </p:txBody>
+      </p:sp>
+      <p:sp>
+        <p:nvSpPr>
+          <p:cNvPr id="7" name="Authors and affiliations"/>
+          <p:cNvSpPr txBox="1"/>
+          <p:nvPr/>
+        </p:nvSpPr>
+        <p:spPr>
+          <a:xfrm>
+            <a:off x="2651760" y="1600200"/>
+            <a:ext cx="19202400" cy="1005840"/>
+          </a:xfrm>
+          <a:prstGeom prst="rect">
+            <a:avLst/>
+          </a:prstGeom>
+          <a:noFill/>
+        </p:spPr>
+        <p:txBody>
+          <a:bodyPr wrap="square" anchor="t" lIns="109728" rIns="109728" tIns="109728" bIns="109728">
+            <a:noAutofit/>
+          </a:bodyPr>
+          <a:lstStyle/>
+          <a:p>
+            <a:pPr algn="l">
+              <a:spcAft>
+                <a:spcPts val="700"/>
+              </a:spcAft>
+            </a:pPr>
+            <a:r>
+              <a:rPr sz="2600" b="1" i="0">
+                <a:solidFill>
+                  <a:srgbClr val="000000"/>
+                </a:solidFill>
+                <a:latin typeface="Arial"/>
+              </a:rPr>
+              <a:t>Your Name</a:t>
+            </a:r>
+            <a:r>
+              <a:rPr sz="2200" b="0" i="0">
+                <a:solidFill>
+                  <a:srgbClr val="000000"/>
+                </a:solidFill>
+                <a:latin typeface="Arial"/>
+              </a:rPr>
+              <a:t>  ·  Your major, Your college  ·  John Martinson Honors College, Purdue University</a:t>
+            </a:r>
+          </a:p>
+          <a:p>
+            <a:pPr algn="l">
+              <a:spcAft>
+                <a:spcPts val="700"/>
+              </a:spcAft>
+            </a:pPr>
+            <a:r>
+              <a:rPr sz="1900" b="0" i="0">
+                <a:solidFill>
+                  <a:srgbClr val="404040"/>
+                </a:solidFill>
+                <a:latin typeface="Arial"/>
+              </a:rPr>
+              <a:t>Faculty mentor: Professor Davi Moreira, Mitch Daniels School of Business  ·  your.email@purdue.edu</a:t>
+            </a:r>
+          </a:p>
+        </p:txBody>
+      </p:sp>
+      <p:pic>
+        <p:nvPicPr>
+          <p:cNvPr id="8" name="Purdue University mark" descr="Purdue University"/>
+          <p:cNvPicPr>
+            <a:picLocks noChangeAspect="1"/>
+          </p:cNvPicPr>
+          <p:nvPr/>
+        </p:nvPicPr>
+        <p:blipFill>
+          <a:blip r:embed="rId4"/>
           <a:srcRect r="45327"/>
           <a:stretch>
             <a:fillRect/>
@@ -3297,8 +3345,8 @@
         </p:blipFill>
         <p:spPr>
           <a:xfrm>
-            <a:off x="30358080" y="685800"/>
-            <a:ext cx="8190497" cy="1600200"/>
+            <a:off x="21945600" y="411480"/>
+            <a:ext cx="5382326" cy="1051560"/>
           </a:xfrm>
           <a:prstGeom prst="rect">
             <a:avLst/>
@@ -3307,14 +3355,14 @@
       </p:pic>
       <p:sp>
         <p:nvSpPr>
-          <p:cNvPr id="7" name="Lockup rule"/>
+          <p:cNvPr id="9" name="Lockup rule"/>
           <p:cNvSpPr/>
           <p:nvPr/>
         </p:nvSpPr>
         <p:spPr>
           <a:xfrm>
-            <a:off x="38868617" y="731520"/>
-            <a:ext cx="36576" cy="1508760"/>
+            <a:off x="27556526" y="457200"/>
+            <a:ext cx="27432" cy="960119"/>
           </a:xfrm>
           <a:prstGeom prst="rect">
             <a:avLst/>
@@ -3351,14 +3399,14 @@
       </p:sp>
       <p:sp>
         <p:nvSpPr>
-          <p:cNvPr id="8" name="Honors College"/>
+          <p:cNvPr id="10" name="Honors College"/>
           <p:cNvSpPr txBox="1"/>
           <p:nvPr/>
         </p:nvSpPr>
         <p:spPr>
           <a:xfrm>
-            <a:off x="39097217" y="640080"/>
-            <a:ext cx="4108182" cy="1737360"/>
+            <a:off x="27693686" y="365760"/>
+            <a:ext cx="2938713" cy="1188720"/>
           </a:xfrm>
           <a:prstGeom prst="rect">
             <a:avLst/>
@@ -3377,7 +3425,7 @@
               </a:spcAft>
             </a:pPr>
             <a:r>
-              <a:rPr sz="3400" b="1" i="0">
+              <a:rPr sz="2400" b="1" i="0">
                 <a:solidFill>
                   <a:srgbClr val="000000"/>
                 </a:solidFill>
@@ -3389,11 +3437,11 @@
           <a:p>
             <a:pPr algn="l">
               <a:spcAft>
-                <a:spcPts val="1000"/>
+                <a:spcPts val="700"/>
               </a:spcAft>
             </a:pPr>
             <a:r>
-              <a:rPr sz="3400" b="1" i="0">
+              <a:rPr sz="2400" b="1" i="0">
                 <a:solidFill>
                   <a:srgbClr val="000000"/>
                 </a:solidFill>
@@ -3406,14 +3454,14 @@
       </p:sp>
       <p:sp>
         <p:nvSpPr>
-          <p:cNvPr id="9" name="Draft tag (delete at the M13 lock)"/>
+          <p:cNvPr id="11" name="Draft tag (delete at the M13 lock)"/>
           <p:cNvSpPr/>
           <p:nvPr/>
         </p:nvSpPr>
         <p:spPr>
           <a:xfrm>
-            <a:off x="34518600" y="2743200"/>
-            <a:ext cx="8686800" cy="960120"/>
+            <a:off x="24688800" y="1783080"/>
+            <a:ext cx="5943600" cy="640080"/>
           </a:xfrm>
           <a:prstGeom prst="roundRect">
             <a:avLst/>
@@ -3452,7 +3500,7 @@
               </a:spcAft>
             </a:pPr>
             <a:r>
-              <a:rPr sz="3000" b="1" i="0">
+              <a:rPr sz="2200" b="1" i="0">
                 <a:solidFill>
                   <a:srgbClr val="FFFFFF"/>
                 </a:solidFill>
@@ -3465,14 +3513,14 @@
       </p:sp>
       <p:sp>
         <p:nvSpPr>
-          <p:cNvPr id="10" name="Headline banner"/>
+          <p:cNvPr id="12" name="Headline banner"/>
           <p:cNvSpPr/>
           <p:nvPr/>
         </p:nvSpPr>
         <p:spPr>
           <a:xfrm>
-            <a:off x="685800" y="4160520"/>
-            <a:ext cx="42519600" cy="2697480"/>
+            <a:off x="457200" y="2697480"/>
+            <a:ext cx="30175200" cy="1691640"/>
           </a:xfrm>
           <a:prstGeom prst="rect">
             <a:avLst/>
@@ -3500,27 +3548,27 @@
           </a:fontRef>
         </p:style>
         <p:txBody>
-          <a:bodyPr rtlCol="0" anchor="ctr" wrap="square" lIns="411480" rIns="411480" tIns="411480" bIns="411480">
+          <a:bodyPr rtlCol="0" anchor="ctr" wrap="square" lIns="274320" rIns="274320" tIns="274320" bIns="274320">
             <a:noAutofit/>
           </a:bodyPr>
           <a:lstStyle/>
           <a:p>
             <a:pPr algn="l">
               <a:spcAft>
-                <a:spcPts val="1000"/>
+                <a:spcPts val="700"/>
               </a:spcAft>
             </a:pPr>
             <a:r>
+              <a:rPr sz="2200" b="1" i="0">
+                <a:solidFill>
+                  <a:srgbClr val="CFB991"/>
+                </a:solidFill>
+                <a:latin typeface="Arial"/>
+              </a:rPr>
+              <a:t>HEADLINE  </a:t>
+            </a:r>
+            <a:r>
               <a:rPr sz="3200" b="1" i="0">
-                <a:solidFill>
-                  <a:srgbClr val="CFB991"/>
-                </a:solidFill>
-                <a:latin typeface="Arial"/>
-              </a:rPr>
-              <a:t>HEADLINE  </a:t>
-            </a:r>
-            <a:r>
-              <a:rPr sz="4600" b="1" i="0">
                 <a:solidFill>
                   <a:srgbClr val="FFFFFF"/>
                 </a:solidFill>
@@ -3532,11 +3580,11 @@
           <a:p>
             <a:pPr algn="l">
               <a:spcAft>
-                <a:spcPts val="1000"/>
+                <a:spcPts val="700"/>
               </a:spcAft>
             </a:pPr>
             <a:r>
-              <a:rPr sz="3200" b="0" i="1">
+              <a:rPr sz="2200" b="0" i="1">
                 <a:solidFill>
                   <a:srgbClr val="CFB991"/>
                 </a:solidFill>
@@ -3549,14 +3597,14 @@
       </p:sp>
       <p:sp>
         <p:nvSpPr>
-          <p:cNvPr id="11" name="Heading: THE QUESTION AND WHAT IT ADDS"/>
+          <p:cNvPr id="13" name="Heading: ABSTRACT"/>
           <p:cNvSpPr/>
           <p:nvPr/>
         </p:nvSpPr>
         <p:spPr>
           <a:xfrm>
-            <a:off x="685800" y="7315200"/>
-            <a:ext cx="11887200" cy="868680"/>
+            <a:off x="457200" y="4663440"/>
+            <a:ext cx="7269480" cy="548640"/>
           </a:xfrm>
           <a:prstGeom prst="rect">
             <a:avLst/>
@@ -3584,7 +3632,7 @@
           </a:fontRef>
         </p:style>
         <p:txBody>
-          <a:bodyPr rtlCol="0" anchor="ctr" wrap="square" lIns="274320" rIns="274320" tIns="274320" bIns="274320">
+          <a:bodyPr rtlCol="0" anchor="ctr" wrap="square" lIns="182880" rIns="182880" tIns="182880" bIns="182880">
             <a:noAutofit/>
           </a:bodyPr>
           <a:lstStyle/>
@@ -3595,27 +3643,27 @@
               </a:spcAft>
             </a:pPr>
             <a:r>
-              <a:rPr sz="3400" b="1" i="0">
+              <a:rPr sz="2400" b="1" i="0">
                 <a:solidFill>
                   <a:srgbClr val="CFB991"/>
                 </a:solidFill>
                 <a:latin typeface="Arial"/>
               </a:rPr>
-              <a:t>THE QUESTION AND WHAT IT ADDS</a:t>
-            </a:r>
-          </a:p>
-        </p:txBody>
-      </p:sp>
-      <p:sp>
-        <p:nvSpPr>
-          <p:cNvPr id="12" name="Question text"/>
+              <a:t>ABSTRACT</a:t>
+            </a:r>
+          </a:p>
+        </p:txBody>
+      </p:sp>
+      <p:sp>
+        <p:nvSpPr>
+          <p:cNvPr id="14" name="Abstract text"/>
           <p:cNvSpPr txBox="1"/>
           <p:nvPr/>
         </p:nvSpPr>
         <p:spPr>
           <a:xfrm>
-            <a:off x="685800" y="8275319"/>
-            <a:ext cx="11887200" cy="7589520"/>
+            <a:off x="457200" y="5257799"/>
+            <a:ext cx="7269480" cy="4023360"/>
           </a:xfrm>
           <a:prstGeom prst="rect">
             <a:avLst/>
@@ -3630,115 +3678,31 @@
           <a:p>
             <a:pPr algn="l">
               <a:spcAft>
-                <a:spcPts val="1000"/>
+                <a:spcPts val="700"/>
               </a:spcAft>
             </a:pPr>
             <a:r>
-              <a:rPr sz="2600" b="1" i="0">
+              <a:rPr sz="1800" b="0" i="0">
                 <a:solidFill>
                   <a:srgbClr val="000000"/>
                 </a:solidFill>
                 <a:latin typeface="Arial"/>
               </a:rPr>
-              <a:t>Your research question,</a:t>
-            </a:r>
-            <a:r>
-              <a:rPr sz="2600" b="0" i="0">
-                <a:solidFill>
-                  <a:srgbClr val="000000"/>
-                </a:solidFill>
-                <a:latin typeface="Arial"/>
-              </a:rPr>
-              <a:t> in one sentence that ends with a question mark, and why it matters, and to whom.</a:t>
-            </a:r>
-          </a:p>
-          <a:p>
-            <a:pPr algn="l">
-              <a:spcAft>
-                <a:spcPts val="1000"/>
-              </a:spcAft>
-            </a:pPr>
-            <a:r>
-              <a:rPr sz="2600" b="1" i="0">
-                <a:solidFill>
-                  <a:srgbClr val="000000"/>
-                </a:solidFill>
-                <a:latin typeface="Arial"/>
-              </a:rPr>
-              <a:t>What the literature already establishes,</a:t>
-            </a:r>
-            <a:r>
-              <a:rPr sz="2600" b="0" i="0">
-                <a:solidFill>
-                  <a:srgbClr val="000000"/>
-                </a:solidFill>
-                <a:latin typeface="Arial"/>
-              </a:rPr>
-              <a:t> from at least two sources you read yourself (Author, Year).</a:t>
-            </a:r>
-          </a:p>
-          <a:p>
-            <a:pPr algn="l">
-              <a:spcAft>
-                <a:spcPts val="1000"/>
-              </a:spcAft>
-            </a:pPr>
-            <a:r>
-              <a:rPr sz="2600" b="1" i="0">
-                <a:solidFill>
-                  <a:srgbClr val="000000"/>
-                </a:solidFill>
-                <a:latin typeface="Arial"/>
-              </a:rPr>
-              <a:t>What your project adds</a:t>
-            </a:r>
-            <a:r>
-              <a:rPr sz="2600" b="0" i="0">
-                <a:solidFill>
-                  <a:srgbClr val="000000"/>
-                </a:solidFill>
-                <a:latin typeface="Arial"/>
-              </a:rPr>
-              <a:t> to that conclusion.</a:t>
-            </a:r>
-          </a:p>
-          <a:p>
-            <a:pPr algn="l">
-              <a:spcAft>
-                <a:spcPts val="1000"/>
-              </a:spcAft>
-            </a:pPr>
-            <a:r>
-              <a:rPr sz="2600" b="1" i="0">
-                <a:solidFill>
-                  <a:srgbClr val="000000"/>
-                </a:solidFill>
-                <a:latin typeface="Arial"/>
-              </a:rPr>
-              <a:t>Your main hypothesis,</a:t>
-            </a:r>
-            <a:r>
-              <a:rPr sz="2600" b="0" i="0">
-                <a:solidFill>
-                  <a:srgbClr val="000000"/>
-                </a:solidFill>
-                <a:latin typeface="Arial"/>
-              </a:rPr>
-              <a:t> as you recorded it before the analysis ran. Label any analysis you added later as exploratory.</a:t>
-            </a:r>
-          </a:p>
-        </p:txBody>
-      </p:sp>
-      <p:sp>
-        <p:nvSpPr>
-          <p:cNvPr id="13" name="Heading: DESIGN: WHAT YOUR CLAIM NEEDS"/>
+              <a:t>Up to 150 words, one paragraph: your OURConnect abstract, updated to your verified results. Keep its four parts in order: the question and its answer; what the literature concludes and what you add; the data and the design; the main result with its uncertainty, and the limitation that matters most.</a:t>
+            </a:r>
+          </a:p>
+        </p:txBody>
+      </p:sp>
+      <p:sp>
+        <p:nvSpPr>
+          <p:cNvPr id="15" name="Heading: THE QUESTION AND WHY IT MATTERS"/>
           <p:cNvSpPr/>
           <p:nvPr/>
         </p:nvSpPr>
         <p:spPr>
           <a:xfrm>
-            <a:off x="685800" y="16047720"/>
-            <a:ext cx="11887200" cy="868680"/>
+            <a:off x="457200" y="9418320"/>
+            <a:ext cx="7269480" cy="548640"/>
           </a:xfrm>
           <a:prstGeom prst="rect">
             <a:avLst/>
@@ -3766,7 +3730,7 @@
           </a:fontRef>
         </p:style>
         <p:txBody>
-          <a:bodyPr rtlCol="0" anchor="ctr" wrap="square" lIns="274320" rIns="274320" tIns="274320" bIns="274320">
+          <a:bodyPr rtlCol="0" anchor="ctr" wrap="square" lIns="182880" rIns="182880" tIns="182880" bIns="182880">
             <a:noAutofit/>
           </a:bodyPr>
           <a:lstStyle/>
@@ -3777,27 +3741,125 @@
               </a:spcAft>
             </a:pPr>
             <a:r>
-              <a:rPr sz="3400" b="1" i="0">
+              <a:rPr sz="2400" b="1" i="0">
                 <a:solidFill>
                   <a:srgbClr val="CFB991"/>
                 </a:solidFill>
                 <a:latin typeface="Arial"/>
               </a:rPr>
-              <a:t>DESIGN: WHAT YOUR CLAIM NEEDS</a:t>
-            </a:r>
-          </a:p>
-        </p:txBody>
-      </p:sp>
-      <p:sp>
-        <p:nvSpPr>
-          <p:cNvPr id="14" name="Compass box: KIND: label"/>
+              <a:t>THE QUESTION AND WHY IT MATTERS</a:t>
+            </a:r>
+          </a:p>
+        </p:txBody>
+      </p:sp>
+      <p:sp>
+        <p:nvSpPr>
+          <p:cNvPr id="16" name="Question text"/>
+          <p:cNvSpPr txBox="1"/>
+          <p:nvPr/>
+        </p:nvSpPr>
+        <p:spPr>
+          <a:xfrm>
+            <a:off x="457200" y="10012680"/>
+            <a:ext cx="7269480" cy="4206240"/>
+          </a:xfrm>
+          <a:prstGeom prst="rect">
+            <a:avLst/>
+          </a:prstGeom>
+          <a:noFill/>
+        </p:spPr>
+        <p:txBody>
+          <a:bodyPr wrap="square" anchor="t" lIns="109728" rIns="109728" tIns="109728" bIns="109728">
+            <a:noAutofit/>
+          </a:bodyPr>
+          <a:lstStyle/>
+          <a:p>
+            <a:pPr algn="l">
+              <a:spcAft>
+                <a:spcPts val="700"/>
+              </a:spcAft>
+            </a:pPr>
+            <a:r>
+              <a:rPr sz="1800" b="1" i="0">
+                <a:solidFill>
+                  <a:srgbClr val="000000"/>
+                </a:solidFill>
+                <a:latin typeface="Arial"/>
+              </a:rPr>
+              <a:t>Your research question,</a:t>
+            </a:r>
+            <a:r>
+              <a:rPr sz="1800" b="0" i="0">
+                <a:solidFill>
+                  <a:srgbClr val="000000"/>
+                </a:solidFill>
+                <a:latin typeface="Arial"/>
+              </a:rPr>
+              <a:t> in one sentence ending with a question mark.</a:t>
+            </a:r>
+          </a:p>
+          <a:p>
+            <a:pPr algn="l">
+              <a:spcAft>
+                <a:spcPts val="700"/>
+              </a:spcAft>
+            </a:pPr>
+            <a:r>
+              <a:rPr sz="1800" b="1" i="0">
+                <a:solidFill>
+                  <a:srgbClr val="000000"/>
+                </a:solidFill>
+                <a:latin typeface="Arial"/>
+              </a:rPr>
+              <a:t>Why it matters, and to whom:</a:t>
+            </a:r>
+            <a:r>
+              <a:rPr sz="1800" b="0" i="0">
+                <a:solidFill>
+                  <a:srgbClr val="000000"/>
+                </a:solidFill>
+                <a:latin typeface="Arial"/>
+              </a:rPr>
+              <a:t> the scientific or practical stake.</a:t>
+            </a:r>
+          </a:p>
+          <a:p>
+            <a:pPr algn="l">
+              <a:spcAft>
+                <a:spcPts val="700"/>
+              </a:spcAft>
+            </a:pPr>
+            <a:r>
+              <a:rPr sz="1800" b="1" i="0">
+                <a:solidFill>
+                  <a:srgbClr val="000000"/>
+                </a:solidFill>
+                <a:latin typeface="Arial"/>
+              </a:rPr>
+              <a:t>Your main hypothesis,</a:t>
+            </a:r>
+            <a:r>
+              <a:rPr sz="1800" b="0" i="0">
+                <a:solidFill>
+                  <a:srgbClr val="000000"/>
+                </a:solidFill>
+                <a:latin typeface="Arial"/>
+              </a:rPr>
+              <a:t> as you recorded it before the analysis ran. Label later analysis as exploratory.</a:t>
+            </a:r>
+          </a:p>
+        </p:txBody>
+      </p:sp>
+      <p:sp>
+        <p:nvSpPr>
+          <p:cNvPr id="17" name="Heading: WHAT IS ALREADY KNOWN"/>
           <p:cNvSpPr/>
           <p:nvPr/>
         </p:nvSpPr>
         <p:spPr>
           <a:xfrm>
-            <a:off x="685800" y="17099280"/>
-            <a:ext cx="2834640" cy="1097280"/>
+            <a:off x="457200" y="14538960"/>
+            <a:ext cx="7269480" cy="548640"/>
           </a:xfrm>
           <a:prstGeom prst="rect">
             <a:avLst/>
@@ -3825,6 +3887,197 @@
           </a:fontRef>
         </p:style>
         <p:txBody>
+          <a:bodyPr rtlCol="0" anchor="ctr" wrap="square" lIns="182880" rIns="182880" tIns="182880" bIns="182880">
+            <a:noAutofit/>
+          </a:bodyPr>
+          <a:lstStyle/>
+          <a:p>
+            <a:pPr algn="l">
+              <a:spcAft>
+                <a:spcPts val="0"/>
+              </a:spcAft>
+            </a:pPr>
+            <a:r>
+              <a:rPr sz="2400" b="1" i="0">
+                <a:solidFill>
+                  <a:srgbClr val="CFB991"/>
+                </a:solidFill>
+                <a:latin typeface="Arial"/>
+              </a:rPr>
+              <a:t>WHAT IS ALREADY KNOWN</a:t>
+            </a:r>
+          </a:p>
+        </p:txBody>
+      </p:sp>
+      <p:sp>
+        <p:nvSpPr>
+          <p:cNvPr id="18" name="Literature text"/>
+          <p:cNvSpPr txBox="1"/>
+          <p:nvPr/>
+        </p:nvSpPr>
+        <p:spPr>
+          <a:xfrm>
+            <a:off x="457200" y="15133320"/>
+            <a:ext cx="7269480" cy="4709159"/>
+          </a:xfrm>
+          <a:prstGeom prst="rect">
+            <a:avLst/>
+          </a:prstGeom>
+          <a:noFill/>
+        </p:spPr>
+        <p:txBody>
+          <a:bodyPr wrap="square" anchor="t" lIns="109728" rIns="109728" tIns="109728" bIns="109728">
+            <a:noAutofit/>
+          </a:bodyPr>
+          <a:lstStyle/>
+          <a:p>
+            <a:pPr algn="l">
+              <a:spcAft>
+                <a:spcPts val="700"/>
+              </a:spcAft>
+            </a:pPr>
+            <a:r>
+              <a:rPr sz="1800" b="1" i="0">
+                <a:solidFill>
+                  <a:srgbClr val="000000"/>
+                </a:solidFill>
+                <a:latin typeface="Arial"/>
+              </a:rPr>
+              <a:t>The main conclusion of the literature,</a:t>
+            </a:r>
+            <a:r>
+              <a:rPr sz="1800" b="0" i="0">
+                <a:solidFill>
+                  <a:srgbClr val="000000"/>
+                </a:solidFill>
+                <a:latin typeface="Arial"/>
+              </a:rPr>
+              <a:t> from at least two sources you read yourself (Author, Year).</a:t>
+            </a:r>
+          </a:p>
+          <a:p>
+            <a:pPr algn="l">
+              <a:spcAft>
+                <a:spcPts val="700"/>
+              </a:spcAft>
+            </a:pPr>
+            <a:r>
+              <a:rPr sz="1800" b="1" i="0">
+                <a:solidFill>
+                  <a:srgbClr val="000000"/>
+                </a:solidFill>
+                <a:latin typeface="Arial"/>
+              </a:rPr>
+              <a:t>The gap,</a:t>
+            </a:r>
+            <a:r>
+              <a:rPr sz="1800" b="0" i="0">
+                <a:solidFill>
+                  <a:srgbClr val="000000"/>
+                </a:solidFill>
+                <a:latin typeface="Arial"/>
+              </a:rPr>
+              <a:t> and what your project adds to that conclusion.</a:t>
+            </a:r>
+          </a:p>
+        </p:txBody>
+      </p:sp>
+      <p:sp>
+        <p:nvSpPr>
+          <p:cNvPr id="19" name="Heading: DESIGN: WHAT YOUR CLAIM NEEDS"/>
+          <p:cNvSpPr/>
+          <p:nvPr/>
+        </p:nvSpPr>
+        <p:spPr>
+          <a:xfrm>
+            <a:off x="8092440" y="4663440"/>
+            <a:ext cx="7269480" cy="548640"/>
+          </a:xfrm>
+          <a:prstGeom prst="rect">
+            <a:avLst/>
+          </a:prstGeom>
+          <a:solidFill>
+            <a:srgbClr val="000000"/>
+          </a:solidFill>
+          <a:ln>
+            <a:noFill/>
+          </a:ln>
+          <a:effectLst/>
+        </p:spPr>
+        <p:style>
+          <a:lnRef idx="1">
+            <a:schemeClr val="accent1"/>
+          </a:lnRef>
+          <a:fillRef idx="3">
+            <a:schemeClr val="accent1"/>
+          </a:fillRef>
+          <a:effectRef idx="2">
+            <a:schemeClr val="accent1"/>
+          </a:effectRef>
+          <a:fontRef idx="minor">
+            <a:schemeClr val="lt1"/>
+          </a:fontRef>
+        </p:style>
+        <p:txBody>
+          <a:bodyPr rtlCol="0" anchor="ctr" wrap="square" lIns="182880" rIns="182880" tIns="182880" bIns="182880">
+            <a:noAutofit/>
+          </a:bodyPr>
+          <a:lstStyle/>
+          <a:p>
+            <a:pPr algn="l">
+              <a:spcAft>
+                <a:spcPts val="0"/>
+              </a:spcAft>
+            </a:pPr>
+            <a:r>
+              <a:rPr sz="2400" b="1" i="0">
+                <a:solidFill>
+                  <a:srgbClr val="CFB991"/>
+                </a:solidFill>
+                <a:latin typeface="Arial"/>
+              </a:rPr>
+              <a:t>DESIGN: WHAT YOUR CLAIM NEEDS</a:t>
+            </a:r>
+          </a:p>
+        </p:txBody>
+      </p:sp>
+      <p:sp>
+        <p:nvSpPr>
+          <p:cNvPr id="20" name="Compass box: KIND: label"/>
+          <p:cNvSpPr/>
+          <p:nvPr/>
+        </p:nvSpPr>
+        <p:spPr>
+          <a:xfrm>
+            <a:off x="8092440" y="5303519"/>
+            <a:ext cx="1600200" cy="777240"/>
+          </a:xfrm>
+          <a:prstGeom prst="rect">
+            <a:avLst/>
+          </a:prstGeom>
+          <a:solidFill>
+            <a:srgbClr val="000000"/>
+          </a:solidFill>
+          <a:ln>
+            <a:noFill/>
+          </a:ln>
+          <a:effectLst/>
+        </p:spPr>
+        <p:style>
+          <a:lnRef idx="1">
+            <a:schemeClr val="accent1"/>
+          </a:lnRef>
+          <a:fillRef idx="3">
+            <a:schemeClr val="accent1"/>
+          </a:fillRef>
+          <a:effectRef idx="2">
+            <a:schemeClr val="accent1"/>
+          </a:effectRef>
+          <a:fontRef idx="minor">
+            <a:schemeClr val="lt1"/>
+          </a:fontRef>
+        </p:style>
+        <p:txBody>
           <a:bodyPr rtlCol="0" anchor="ctr" wrap="square" tIns="91440" bIns="91440">
             <a:noAutofit/>
           </a:bodyPr>
@@ -3836,7 +4089,7 @@
               </a:spcAft>
             </a:pPr>
             <a:r>
-              <a:rPr sz="2200" b="1" i="0">
+              <a:rPr sz="1500" b="1" i="0">
                 <a:solidFill>
                   <a:srgbClr val="CFB991"/>
                 </a:solidFill>
@@ -3849,14 +4102,14 @@
       </p:sp>
       <p:sp>
         <p:nvSpPr>
-          <p:cNvPr id="15" name="Compass box: KIND"/>
+          <p:cNvPr id="21" name="Compass box: KIND"/>
           <p:cNvSpPr/>
           <p:nvPr/>
         </p:nvSpPr>
         <p:spPr>
           <a:xfrm>
-            <a:off x="3520440" y="17099280"/>
-            <a:ext cx="9052560" cy="1097280"/>
+            <a:off x="9692640" y="5303519"/>
+            <a:ext cx="5669280" cy="777240"/>
           </a:xfrm>
           <a:prstGeom prst="rect">
             <a:avLst/>
@@ -3897,27 +4150,27 @@
               </a:spcAft>
             </a:pPr>
             <a:r>
-              <a:rPr sz="2400" b="0" i="0">
+              <a:rPr sz="1800" b="0" i="0">
                 <a:solidFill>
                   <a:srgbClr val="000000"/>
                 </a:solidFill>
                 <a:latin typeface="Arial"/>
               </a:rPr>
-              <a:t>☐ Descriptive   ☐ Causal.  If your aim is prediction, say so here.</a:t>
-            </a:r>
-          </a:p>
-        </p:txBody>
-      </p:sp>
-      <p:sp>
-        <p:nvSpPr>
-          <p:cNvPr id="16" name="Compass box: REACH: label"/>
+              <a:t>☐ Descriptive  ☐ Causal. If your aim is prediction, say so.</a:t>
+            </a:r>
+          </a:p>
+        </p:txBody>
+      </p:sp>
+      <p:sp>
+        <p:nvSpPr>
+          <p:cNvPr id="22" name="Compass box: REACH: label"/>
           <p:cNvSpPr/>
           <p:nvPr/>
         </p:nvSpPr>
         <p:spPr>
           <a:xfrm>
-            <a:off x="685800" y="18333720"/>
-            <a:ext cx="2834640" cy="1600200"/>
+            <a:off x="8092440" y="6153911"/>
+            <a:ext cx="1600200" cy="1051560"/>
           </a:xfrm>
           <a:prstGeom prst="rect">
             <a:avLst/>
@@ -3956,7 +4209,7 @@
               </a:spcAft>
             </a:pPr>
             <a:r>
-              <a:rPr sz="2200" b="1" i="0">
+              <a:rPr sz="1500" b="1" i="0">
                 <a:solidFill>
                   <a:srgbClr val="CFB991"/>
                 </a:solidFill>
@@ -3969,14 +4222,14 @@
       </p:sp>
       <p:sp>
         <p:nvSpPr>
-          <p:cNvPr id="17" name="Compass box: REACH"/>
+          <p:cNvPr id="23" name="Compass box: REACH"/>
           <p:cNvSpPr/>
           <p:nvPr/>
         </p:nvSpPr>
         <p:spPr>
           <a:xfrm>
-            <a:off x="3520440" y="18333720"/>
-            <a:ext cx="9052560" cy="1600200"/>
+            <a:off x="9692640" y="6153911"/>
+            <a:ext cx="5669280" cy="1051560"/>
           </a:xfrm>
           <a:prstGeom prst="rect">
             <a:avLst/>
@@ -4017,27 +4270,27 @@
               </a:spcAft>
             </a:pPr>
             <a:r>
-              <a:rPr sz="2400" b="0" i="0">
+              <a:rPr sz="1800" b="0" i="0">
                 <a:solidFill>
                   <a:srgbClr val="000000"/>
                 </a:solidFill>
                 <a:latin typeface="Arial"/>
               </a:rPr>
-              <a:t>☐ A population beyond your data: name its units, setting, and period.  ☐ Unseen cases: which ones, from which population.</a:t>
-            </a:r>
-          </a:p>
-        </p:txBody>
-      </p:sp>
-      <p:sp>
-        <p:nvSpPr>
-          <p:cNvPr id="18" name="Compass box: TARGET: label"/>
+              <a:t>☐ A population beyond your data (units, setting, period)  ☐ Unseen cases: which, from where.</a:t>
+            </a:r>
+          </a:p>
+        </p:txBody>
+      </p:sp>
+      <p:sp>
+        <p:nvSpPr>
+          <p:cNvPr id="24" name="Compass box: TARGET: label"/>
           <p:cNvSpPr/>
           <p:nvPr/>
         </p:nvSpPr>
         <p:spPr>
           <a:xfrm>
-            <a:off x="685800" y="20071080"/>
-            <a:ext cx="2834640" cy="1600200"/>
+            <a:off x="8092440" y="7278623"/>
+            <a:ext cx="1600200" cy="1051560"/>
           </a:xfrm>
           <a:prstGeom prst="rect">
             <a:avLst/>
@@ -4076,7 +4329,7 @@
               </a:spcAft>
             </a:pPr>
             <a:r>
-              <a:rPr sz="2200" b="1" i="0">
+              <a:rPr sz="1500" b="1" i="0">
                 <a:solidFill>
                   <a:srgbClr val="CFB991"/>
                 </a:solidFill>
@@ -4089,14 +4342,14 @@
       </p:sp>
       <p:sp>
         <p:nvSpPr>
-          <p:cNvPr id="19" name="Compass box: TARGET"/>
+          <p:cNvPr id="25" name="Compass box: TARGET"/>
           <p:cNvSpPr/>
           <p:nvPr/>
         </p:nvSpPr>
         <p:spPr>
           <a:xfrm>
-            <a:off x="3520440" y="20071080"/>
-            <a:ext cx="9052560" cy="1600200"/>
+            <a:off x="9692640" y="7278623"/>
+            <a:ext cx="5669280" cy="1051560"/>
           </a:xfrm>
           <a:prstGeom prst="rect">
             <a:avLst/>
@@ -4137,27 +4390,27 @@
               </a:spcAft>
             </a:pPr>
             <a:r>
-              <a:rPr sz="2400" b="0" i="0">
+              <a:rPr sz="1800" b="0" i="0">
                 <a:solidFill>
                   <a:srgbClr val="000000"/>
                 </a:solidFill>
                 <a:latin typeface="Arial"/>
               </a:rPr>
-              <a:t>The exact quantity you estimate or predict: outcome, comparison, units, time frame.</a:t>
-            </a:r>
-          </a:p>
-        </p:txBody>
-      </p:sp>
-      <p:sp>
-        <p:nvSpPr>
-          <p:cNvPr id="20" name="Compass box: WARRANT: label"/>
+              <a:t>The exact quantity you estimate or predict: outcome, comparison, units, time.</a:t>
+            </a:r>
+          </a:p>
+        </p:txBody>
+      </p:sp>
+      <p:sp>
+        <p:nvSpPr>
+          <p:cNvPr id="26" name="Compass box: WARRANT: label"/>
           <p:cNvSpPr/>
           <p:nvPr/>
         </p:nvSpPr>
         <p:spPr>
           <a:xfrm>
-            <a:off x="685800" y="21808439"/>
-            <a:ext cx="2834640" cy="2514600"/>
+            <a:off x="8092440" y="8403336"/>
+            <a:ext cx="1600200" cy="1325880"/>
           </a:xfrm>
           <a:prstGeom prst="rect">
             <a:avLst/>
@@ -4196,7 +4449,7 @@
               </a:spcAft>
             </a:pPr>
             <a:r>
-              <a:rPr sz="2200" b="1" i="0">
+              <a:rPr sz="1500" b="1" i="0">
                 <a:solidFill>
                   <a:srgbClr val="CFB991"/>
                 </a:solidFill>
@@ -4209,14 +4462,14 @@
       </p:sp>
       <p:sp>
         <p:nvSpPr>
-          <p:cNvPr id="21" name="Compass box: WARRANT"/>
+          <p:cNvPr id="27" name="Compass box: WARRANT"/>
           <p:cNvSpPr/>
           <p:nvPr/>
         </p:nvSpPr>
         <p:spPr>
           <a:xfrm>
-            <a:off x="3520440" y="21808439"/>
-            <a:ext cx="9052560" cy="2514600"/>
+            <a:off x="9692640" y="8403336"/>
+            <a:ext cx="5669280" cy="1325880"/>
           </a:xfrm>
           <a:prstGeom prst="rect">
             <a:avLst/>
@@ -4257,27 +4510,27 @@
               </a:spcAft>
             </a:pPr>
             <a:r>
-              <a:rPr sz="2400" b="0" i="0">
+              <a:rPr sz="1800" b="0" i="0">
                 <a:solidFill>
                   <a:srgbClr val="000000"/>
                 </a:solidFill>
                 <a:latin typeface="Arial"/>
               </a:rPr>
-              <a:t>What carries the claim across: sampling → a population · assignment or identification (with its assumptions) → a cause · a held-out test against a baseline → unseen cases. Then: what your evidence cannot yet support.</a:t>
-            </a:r>
-          </a:p>
-        </p:txBody>
-      </p:sp>
-      <p:sp>
-        <p:nvSpPr>
-          <p:cNvPr id="22" name="Heading: DATA AND MEASUREMENT"/>
+              <a:t>Sampling → a population · assignment or identification (with assumptions) → a cause · held-out test vs. a baseline → unseen cases.</a:t>
+            </a:r>
+          </a:p>
+        </p:txBody>
+      </p:sp>
+      <p:sp>
+        <p:nvSpPr>
+          <p:cNvPr id="28" name="Heading: DATA AND MEASUREMENT"/>
           <p:cNvSpPr/>
           <p:nvPr/>
         </p:nvSpPr>
         <p:spPr>
           <a:xfrm>
-            <a:off x="685800" y="24688799"/>
-            <a:ext cx="11887200" cy="868680"/>
+            <a:off x="8092440" y="10058400"/>
+            <a:ext cx="7269480" cy="548640"/>
           </a:xfrm>
           <a:prstGeom prst="rect">
             <a:avLst/>
@@ -4305,7 +4558,7 @@
           </a:fontRef>
         </p:style>
         <p:txBody>
-          <a:bodyPr rtlCol="0" anchor="ctr" wrap="square" lIns="274320" rIns="274320" tIns="274320" bIns="274320">
+          <a:bodyPr rtlCol="0" anchor="ctr" wrap="square" lIns="182880" rIns="182880" tIns="182880" bIns="182880">
             <a:noAutofit/>
           </a:bodyPr>
           <a:lstStyle/>
@@ -4316,7 +4569,7 @@
               </a:spcAft>
             </a:pPr>
             <a:r>
-              <a:rPr sz="3400" b="1" i="0">
+              <a:rPr sz="2400" b="1" i="0">
                 <a:solidFill>
                   <a:srgbClr val="CFB991"/>
                 </a:solidFill>
@@ -4329,15 +4582,15 @@
       </p:sp>
       <p:graphicFrame>
         <p:nvGraphicFramePr>
-          <p:cNvPr id="23" name="Data card"/>
+          <p:cNvPr id="29" name="Data card"/>
           <p:cNvGraphicFramePr>
             <a:graphicFrameLocks noGrp="1"/>
           </p:cNvGraphicFramePr>
           <p:nvPr/>
         </p:nvGraphicFramePr>
         <p:xfrm>
-          <a:off x="685800" y="25740359"/>
-          <a:ext cx="11887200" cy="4608576"/>
+          <a:off x="8092440" y="10698480"/>
+          <a:ext cx="7269480" cy="3200400"/>
         </p:xfrm>
         <a:graphic>
           <a:graphicData uri="http://schemas.openxmlformats.org/drawingml/2006/table">
@@ -4346,17 +4599,17 @@
                 <a:tableStyleId>{5C22544A-7EE6-4342-B048-85BDC9FD1C3A}</a:tableStyleId>
               </a:tblPr>
               <a:tblGrid>
-                <a:gridCol w="3291840"/>
-                <a:gridCol w="8595360"/>
+                <a:gridCol w="2240280"/>
+                <a:gridCol w="5029200"/>
               </a:tblGrid>
-              <a:tr h="658368">
+              <a:tr h="457200">
                 <a:tc>
                   <a:txBody>
                     <a:bodyPr wrap="square"/>
                     <a:lstStyle/>
                     <a:p>
                       <a:r>
-                        <a:rPr sz="2400" b="1">
+                        <a:rPr sz="1800" b="1">
                           <a:solidFill>
                             <a:srgbClr val="000000"/>
                           </a:solidFill>
@@ -4366,7 +4619,7 @@
                       </a:r>
                     </a:p>
                   </a:txBody>
-                  <a:tcPr marL="109728" marR="109728" marT="54864" marB="54864">
+                  <a:tcPr marL="73152" marR="73152" marT="27432" marB="27432">
                     <a:solidFill>
                       <a:srgbClr val="FFFFFF"/>
                     </a:solidFill>
@@ -4378,31 +4631,31 @@
                     <a:lstStyle/>
                     <a:p>
                       <a:r>
-                        <a:rPr sz="2400" b="0">
+                        <a:rPr sz="1800" b="0">
                           <a:solidFill>
                             <a:srgbClr val="000000"/>
                           </a:solidFill>
                           <a:latin typeface="Arial"/>
                         </a:rPr>
-                        <a:t>[archive, URL or DOI, retrieval date; or your collection protocol]</a:t>
+                        <a:t>[archive, URL or DOI, retrieval date; or protocol]</a:t>
                       </a:r>
                     </a:p>
                   </a:txBody>
-                  <a:tcPr marL="109728" marR="109728" marT="54864" marB="54864">
+                  <a:tcPr marL="73152" marR="73152" marT="27432" marB="27432">
                     <a:solidFill>
                       <a:srgbClr val="FFFFFF"/>
                     </a:solidFill>
                   </a:tcPr>
                 </a:tc>
               </a:tr>
-              <a:tr h="658368">
+              <a:tr h="457200">
                 <a:tc>
                   <a:txBody>
                     <a:bodyPr wrap="square"/>
                     <a:lstStyle/>
                     <a:p>
                       <a:r>
-                        <a:rPr sz="2400" b="1">
+                        <a:rPr sz="1800" b="1">
                           <a:solidFill>
                             <a:srgbClr val="000000"/>
                           </a:solidFill>
@@ -4412,7 +4665,7 @@
                       </a:r>
                     </a:p>
                   </a:txBody>
-                  <a:tcPr marL="109728" marR="109728" marT="54864" marB="54864">
+                  <a:tcPr marL="73152" marR="73152" marT="27432" marB="27432">
                     <a:solidFill>
                       <a:srgbClr val="FFFFFF"/>
                     </a:solidFill>
@@ -4424,31 +4677,31 @@
                     <a:lstStyle/>
                     <a:p>
                       <a:r>
-                        <a:rPr sz="2400" b="0">
+                        <a:rPr sz="1800" b="0">
                           <a:solidFill>
                             <a:srgbClr val="000000"/>
                           </a:solidFill>
                           <a:latin typeface="Arial"/>
                         </a:rPr>
-                        <a:t>[number of rows or measurements]</a:t>
+                        <a:t>[rows or measurements]</a:t>
                       </a:r>
                     </a:p>
                   </a:txBody>
-                  <a:tcPr marL="109728" marR="109728" marT="54864" marB="54864">
+                  <a:tcPr marL="73152" marR="73152" marT="27432" marB="27432">
                     <a:solidFill>
                       <a:srgbClr val="FFFFFF"/>
                     </a:solidFill>
                   </a:tcPr>
                 </a:tc>
               </a:tr>
-              <a:tr h="658368">
+              <a:tr h="457200">
                 <a:tc>
                   <a:txBody>
                     <a:bodyPr wrap="square"/>
                     <a:lstStyle/>
                     <a:p>
                       <a:r>
-                        <a:rPr sz="2400" b="1">
+                        <a:rPr sz="1800" b="1">
                           <a:solidFill>
                             <a:srgbClr val="000000"/>
                           </a:solidFill>
@@ -4458,7 +4711,7 @@
                       </a:r>
                     </a:p>
                   </a:txBody>
-                  <a:tcPr marL="109728" marR="109728" marT="54864" marB="54864">
+                  <a:tcPr marL="73152" marR="73152" marT="27432" marB="27432">
                     <a:solidFill>
                       <a:srgbClr val="FFFFFF"/>
                     </a:solidFill>
@@ -4470,31 +4723,31 @@
                     <a:lstStyle/>
                     <a:p>
                       <a:r>
-                        <a:rPr sz="2400" b="0">
+                        <a:rPr sz="1800" b="0">
                           <a:solidFill>
                             <a:srgbClr val="000000"/>
                           </a:solidFill>
                           <a:latin typeface="Arial"/>
                         </a:rPr>
-                        <a:t>[people, sites, groups …] and how observations are grouped</a:t>
+                        <a:t>[people, sites, groups …]; how grouped</a:t>
                       </a:r>
                     </a:p>
                   </a:txBody>
-                  <a:tcPr marL="109728" marR="109728" marT="54864" marB="54864">
+                  <a:tcPr marL="73152" marR="73152" marT="27432" marB="27432">
                     <a:solidFill>
                       <a:srgbClr val="FFFFFF"/>
                     </a:solidFill>
                   </a:tcPr>
                 </a:tc>
               </a:tr>
-              <a:tr h="658368">
+              <a:tr h="457200">
                 <a:tc>
                   <a:txBody>
                     <a:bodyPr wrap="square"/>
                     <a:lstStyle/>
                     <a:p>
                       <a:r>
-                        <a:rPr sz="2400" b="1">
+                        <a:rPr sz="1800" b="1">
                           <a:solidFill>
                             <a:srgbClr val="000000"/>
                           </a:solidFill>
@@ -4504,7 +4757,7 @@
                       </a:r>
                     </a:p>
                   </a:txBody>
-                  <a:tcPr marL="109728" marR="109728" marT="54864" marB="54864">
+                  <a:tcPr marL="73152" marR="73152" marT="27432" marB="27432">
                     <a:solidFill>
                       <a:srgbClr val="FFFFFF"/>
                     </a:solidFill>
@@ -4516,7 +4769,7 @@
                     <a:lstStyle/>
                     <a:p>
                       <a:r>
-                        <a:rPr sz="2400" b="0">
+                        <a:rPr sz="1800" b="0">
                           <a:solidFill>
                             <a:srgbClr val="000000"/>
                           </a:solidFill>
@@ -4526,21 +4779,21 @@
                       </a:r>
                     </a:p>
                   </a:txBody>
-                  <a:tcPr marL="109728" marR="109728" marT="54864" marB="54864">
+                  <a:tcPr marL="73152" marR="73152" marT="27432" marB="27432">
                     <a:solidFill>
                       <a:srgbClr val="FFFFFF"/>
                     </a:solidFill>
                   </a:tcPr>
                 </a:tc>
               </a:tr>
-              <a:tr h="658368">
+              <a:tr h="457200">
                 <a:tc>
                   <a:txBody>
                     <a:bodyPr wrap="square"/>
                     <a:lstStyle/>
                     <a:p>
                       <a:r>
-                        <a:rPr sz="2400" b="1">
+                        <a:rPr sz="1800" b="1">
                           <a:solidFill>
                             <a:srgbClr val="000000"/>
                           </a:solidFill>
@@ -4550,7 +4803,7 @@
                       </a:r>
                     </a:p>
                   </a:txBody>
-                  <a:tcPr marL="109728" marR="109728" marT="54864" marB="54864">
+                  <a:tcPr marL="73152" marR="73152" marT="27432" marB="27432">
                     <a:solidFill>
                       <a:srgbClr val="FFFFFF"/>
                     </a:solidFill>
@@ -4562,31 +4815,31 @@
                     <a:lstStyle/>
                     <a:p>
                       <a:r>
-                        <a:rPr sz="2400" b="0">
+                        <a:rPr sz="1800" b="0">
                           <a:solidFill>
                             <a:srgbClr val="000000"/>
                           </a:solidFill>
                           <a:latin typeface="Arial"/>
                         </a:rPr>
-                        <a:t>[concept] → [variable or item]; main validity concern</a:t>
+                        <a:t>[concept] → [variable]; validity concern</a:t>
                       </a:r>
                     </a:p>
                   </a:txBody>
-                  <a:tcPr marL="109728" marR="109728" marT="54864" marB="54864">
+                  <a:tcPr marL="73152" marR="73152" marT="27432" marB="27432">
                     <a:solidFill>
                       <a:srgbClr val="FFFFFF"/>
                     </a:solidFill>
                   </a:tcPr>
                 </a:tc>
               </a:tr>
-              <a:tr h="658368">
+              <a:tr h="457200">
                 <a:tc>
                   <a:txBody>
                     <a:bodyPr wrap="square"/>
                     <a:lstStyle/>
                     <a:p>
                       <a:r>
-                        <a:rPr sz="2400" b="1">
+                        <a:rPr sz="1800" b="1">
                           <a:solidFill>
                             <a:srgbClr val="000000"/>
                           </a:solidFill>
@@ -4596,7 +4849,7 @@
                       </a:r>
                     </a:p>
                   </a:txBody>
-                  <a:tcPr marL="109728" marR="109728" marT="54864" marB="54864">
+                  <a:tcPr marL="73152" marR="73152" marT="27432" marB="27432">
                     <a:solidFill>
                       <a:srgbClr val="FFFFFF"/>
                     </a:solidFill>
@@ -4608,31 +4861,31 @@
                     <a:lstStyle/>
                     <a:p>
                       <a:r>
-                        <a:rPr sz="2400" b="0">
+                        <a:rPr sz="1800" b="0">
                           <a:solidFill>
                             <a:srgbClr val="000000"/>
                           </a:solidFill>
                           <a:latin typeface="Arial"/>
                         </a:rPr>
-                        <a:t>[how much, and what you did]</a:t>
+                        <a:t>[how much; what you did]</a:t>
                       </a:r>
                     </a:p>
                   </a:txBody>
-                  <a:tcPr marL="109728" marR="109728" marT="54864" marB="54864">
+                  <a:tcPr marL="73152" marR="73152" marT="27432" marB="27432">
                     <a:solidFill>
                       <a:srgbClr val="FFFFFF"/>
                     </a:solidFill>
                   </a:tcPr>
                 </a:tc>
               </a:tr>
-              <a:tr h="658368">
+              <a:tr h="457200">
                 <a:tc>
                   <a:txBody>
                     <a:bodyPr wrap="square"/>
                     <a:lstStyle/>
                     <a:p>
                       <a:r>
-                        <a:rPr sz="2400" b="1">
+                        <a:rPr sz="1800" b="1">
                           <a:solidFill>
                             <a:srgbClr val="000000"/>
                           </a:solidFill>
@@ -4642,7 +4895,7 @@
                       </a:r>
                     </a:p>
                   </a:txBody>
-                  <a:tcPr marL="109728" marR="109728" marT="54864" marB="54864">
+                  <a:tcPr marL="73152" marR="73152" marT="27432" marB="27432">
                     <a:solidFill>
                       <a:srgbClr val="FFFFFF"/>
                     </a:solidFill>
@@ -4654,7 +4907,7 @@
                     <a:lstStyle/>
                     <a:p>
                       <a:r>
-                        <a:rPr sz="2400" b="0">
+                        <a:rPr sz="1800" b="0">
                           <a:solidFill>
                             <a:srgbClr val="000000"/>
                           </a:solidFill>
@@ -4664,7 +4917,7 @@
                       </a:r>
                     </a:p>
                   </a:txBody>
-                  <a:tcPr marL="109728" marR="109728" marT="54864" marB="54864">
+                  <a:tcPr marL="73152" marR="73152" marT="27432" marB="27432">
                     <a:solidFill>
                       <a:srgbClr val="FFFFFF"/>
                     </a:solidFill>
@@ -4677,14 +4930,14 @@
       </p:graphicFrame>
       <p:sp>
         <p:nvSpPr>
-          <p:cNvPr id="24" name="Heading: MAIN RESULT"/>
+          <p:cNvPr id="30" name="Heading: METHODS"/>
           <p:cNvSpPr/>
           <p:nvPr/>
         </p:nvSpPr>
         <p:spPr>
           <a:xfrm>
-            <a:off x="13258800" y="7315200"/>
-            <a:ext cx="17373600" cy="868680"/>
+            <a:off x="8092440" y="14950440"/>
+            <a:ext cx="7269480" cy="548640"/>
           </a:xfrm>
           <a:prstGeom prst="rect">
             <a:avLst/>
@@ -4712,7 +4965,7 @@
           </a:fontRef>
         </p:style>
         <p:txBody>
-          <a:bodyPr rtlCol="0" anchor="ctr" wrap="square" lIns="274320" rIns="274320" tIns="274320" bIns="274320">
+          <a:bodyPr rtlCol="0" anchor="ctr" wrap="square" lIns="182880" rIns="182880" tIns="182880" bIns="182880">
             <a:noAutofit/>
           </a:bodyPr>
           <a:lstStyle/>
@@ -4723,27 +4976,27 @@
               </a:spcAft>
             </a:pPr>
             <a:r>
-              <a:rPr sz="3400" b="1" i="0">
+              <a:rPr sz="2400" b="1" i="0">
                 <a:solidFill>
                   <a:srgbClr val="CFB991"/>
                 </a:solidFill>
                 <a:latin typeface="Arial"/>
               </a:rPr>
-              <a:t>MAIN RESULT</a:t>
-            </a:r>
-          </a:p>
-        </p:txBody>
-      </p:sp>
-      <p:sp>
-        <p:nvSpPr>
-          <p:cNvPr id="25" name="Example stamp"/>
+              <a:t>METHODS</a:t>
+            </a:r>
+          </a:p>
+        </p:txBody>
+      </p:sp>
+      <p:sp>
+        <p:nvSpPr>
+          <p:cNvPr id="31" name="Methods text"/>
           <p:cNvSpPr txBox="1"/>
           <p:nvPr/>
         </p:nvSpPr>
         <p:spPr>
           <a:xfrm>
-            <a:off x="13258800" y="8275319"/>
-            <a:ext cx="17373600" cy="594360"/>
+            <a:off x="8092440" y="15544800"/>
+            <a:ext cx="7269480" cy="4297679"/>
           </a:xfrm>
           <a:prstGeom prst="rect">
             <a:avLst/>
@@ -4758,151 +5011,90 @@
           <a:p>
             <a:pPr algn="l">
               <a:spcAft>
-                <a:spcPts val="0"/>
+                <a:spcPts val="700"/>
               </a:spcAft>
             </a:pPr>
             <a:r>
-              <a:rPr sz="2200" b="1" i="0">
-                <a:solidFill>
-                  <a:srgbClr val="8A1C2B"/>
-                </a:solidFill>
-                <a:latin typeface="Arial"/>
-              </a:rPr>
-              <a:t>EXAMPLE · replace it with the figure your notebook produced, and replace its alt text with yours</a:t>
-            </a:r>
-          </a:p>
-        </p:txBody>
-      </p:sp>
-      <p:pic>
-        <p:nvPicPr>
-          <p:cNvPr id="26" name="Example figure (replace)" descr="Simulated example. Left: mean checkout completion rate by version, A about 71 percent and B about 74 percent, each with a 95 percent interval of about plus or minus 4 points. Right: the difference, B minus A, 3.2 points, with a 95 percent interval from −2.5 to 9.0 points that crosses zero."/>
-          <p:cNvPicPr>
-            <a:picLocks noChangeAspect="1"/>
-          </p:cNvPicPr>
-          <p:nvPr/>
-        </p:nvPicPr>
-        <p:blipFill>
-          <a:blip r:embed="rId3"/>
-          <a:stretch>
-            <a:fillRect/>
-          </a:stretch>
-        </p:blipFill>
-        <p:spPr>
-          <a:xfrm>
-            <a:off x="13258800" y="8915400"/>
-            <a:ext cx="17373600" cy="10058400"/>
-          </a:xfrm>
-          <a:prstGeom prst="rect">
-            <a:avLst/>
-          </a:prstGeom>
-        </p:spPr>
-      </p:pic>
-      <p:sp>
-        <p:nvSpPr>
-          <p:cNvPr id="27" name="Figure caption"/>
-          <p:cNvSpPr txBox="1"/>
-          <p:nvPr/>
-        </p:nvSpPr>
-        <p:spPr>
-          <a:xfrm>
-            <a:off x="13258800" y="19065240"/>
-            <a:ext cx="17373600" cy="1691640"/>
-          </a:xfrm>
-          <a:prstGeom prst="rect">
-            <a:avLst/>
-          </a:prstGeom>
-          <a:noFill/>
-        </p:spPr>
-        <p:txBody>
-          <a:bodyPr wrap="square" anchor="t" lIns="109728" rIns="109728" tIns="109728" bIns="109728">
-            <a:noAutofit/>
-          </a:bodyPr>
-          <a:lstStyle/>
+              <a:rPr sz="1800" b="1" i="0">
+                <a:solidFill>
+                  <a:srgbClr val="000000"/>
+                </a:solidFill>
+                <a:latin typeface="Arial"/>
+              </a:rPr>
+              <a:t>Analysis:</a:t>
+            </a:r>
+            <a:r>
+              <a:rPr sz="1800" b="0" i="0">
+                <a:solidFill>
+                  <a:srgbClr val="000000"/>
+                </a:solidFill>
+                <a:latin typeface="Arial"/>
+              </a:rPr>
+              <a:t> the comparison, estimator, or model you declared before seeing results, and why it fits your design; any later change, and why.</a:t>
+            </a:r>
+          </a:p>
           <a:p>
             <a:pPr algn="l">
               <a:spcAft>
-                <a:spcPts val="1000"/>
+                <a:spcPts val="700"/>
               </a:spcAft>
             </a:pPr>
             <a:r>
-              <a:rPr sz="2000" b="1" i="0">
+              <a:rPr sz="1800" b="1" i="0">
                 <a:solidFill>
                   <a:srgbClr val="000000"/>
                 </a:solidFill>
                 <a:latin typeface="Arial"/>
               </a:rPr>
-              <a:t>Fig. 1.</a:t>
-            </a:r>
-            <a:r>
-              <a:rPr sz="2000" b="0" i="0">
+              <a:t>Uncertainty:</a:t>
+            </a:r>
+            <a:r>
+              <a:rPr sz="1800" b="0" i="0">
                 <a:solidFill>
                   <a:srgbClr val="000000"/>
                 </a:solidFill>
                 <a:latin typeface="Arial"/>
               </a:rPr>
-              <a:t> Say what the figure shows and for which units; n = [observations] from [independent units]; the interval's type, level and method; bars start at zero. Source: [notebook], cell [N]. In the example, panel (b) carries the comparison the headline is about: the interval of the difference, not whether the two intervals in (a) overlap.</a:t>
-            </a:r>
-          </a:p>
-        </p:txBody>
-      </p:sp>
-      <p:sp>
-        <p:nvSpPr>
-          <p:cNvPr id="28" name="Result text"/>
-          <p:cNvSpPr txBox="1"/>
-          <p:nvPr/>
-        </p:nvSpPr>
-        <p:spPr>
-          <a:xfrm>
-            <a:off x="13258800" y="20848320"/>
-            <a:ext cx="17373600" cy="1828800"/>
-          </a:xfrm>
-          <a:prstGeom prst="rect">
-            <a:avLst/>
-          </a:prstGeom>
-          <a:noFill/>
-        </p:spPr>
-        <p:txBody>
-          <a:bodyPr wrap="square" anchor="t" lIns="109728" rIns="109728" tIns="109728" bIns="109728">
-            <a:noAutofit/>
-          </a:bodyPr>
-          <a:lstStyle/>
+              <a:t> how you computed it, at the level of your independent unit, with any dependence named.</a:t>
+            </a:r>
+          </a:p>
           <a:p>
             <a:pPr algn="l">
               <a:spcAft>
-                <a:spcPts val="1000"/>
+                <a:spcPts val="700"/>
               </a:spcAft>
             </a:pPr>
             <a:r>
-              <a:rPr sz="2600" b="1" i="0">
+              <a:rPr sz="1800" b="1" i="0">
                 <a:solidFill>
                   <a:srgbClr val="000000"/>
                 </a:solidFill>
                 <a:latin typeface="Arial"/>
               </a:rPr>
-              <a:t>The result,</a:t>
-            </a:r>
-            <a:r>
-              <a:rPr sz="2600" b="0" i="0">
+              <a:t>Tools:</a:t>
+            </a:r>
+            <a:r>
+              <a:rPr sz="1800" b="0" i="0">
                 <a:solidFill>
                   <a:srgbClr val="000000"/>
                 </a:solidFill>
                 <a:latin typeface="Arial"/>
               </a:rPr>
-              <a:t> in one or two sentences: the estimate, its units, and the uncertainty it warrants (an interval, or a precise caveat saying why none is warranted), in the words your boundary allows.</a:t>
-            </a:r>
-          </a:p>
-        </p:txBody>
-      </p:sp>
-      <p:sp>
-        <p:nvSpPr>
-          <p:cNvPr id="29" name="Heading: CHECKS AND VERIFICATION"/>
+              <a:t> software, seed (SEED = 464), and where the notebook lives.</a:t>
+            </a:r>
+          </a:p>
+        </p:txBody>
+      </p:sp>
+      <p:sp>
+        <p:nvSpPr>
+          <p:cNvPr id="32" name="Heading: MAIN RESULT"/>
           <p:cNvSpPr/>
           <p:nvPr/>
         </p:nvSpPr>
         <p:spPr>
           <a:xfrm>
-            <a:off x="13258800" y="25877520"/>
-            <a:ext cx="17373600" cy="868680"/>
+            <a:off x="15727680" y="4663440"/>
+            <a:ext cx="7269480" cy="548640"/>
           </a:xfrm>
           <a:prstGeom prst="rect">
             <a:avLst/>
@@ -4930,7 +5122,7 @@
           </a:fontRef>
         </p:style>
         <p:txBody>
-          <a:bodyPr rtlCol="0" anchor="ctr" wrap="square" lIns="274320" rIns="274320" tIns="274320" bIns="274320">
+          <a:bodyPr rtlCol="0" anchor="ctr" wrap="square" lIns="182880" rIns="182880" tIns="182880" bIns="182880">
             <a:noAutofit/>
           </a:bodyPr>
           <a:lstStyle/>
@@ -4941,27 +5133,27 @@
               </a:spcAft>
             </a:pPr>
             <a:r>
-              <a:rPr sz="3400" b="1" i="0">
+              <a:rPr sz="2400" b="1" i="0">
                 <a:solidFill>
                   <a:srgbClr val="CFB991"/>
                 </a:solidFill>
                 <a:latin typeface="Arial"/>
               </a:rPr>
-              <a:t>CHECKS AND VERIFICATION</a:t>
-            </a:r>
-          </a:p>
-        </p:txBody>
-      </p:sp>
-      <p:sp>
-        <p:nvSpPr>
-          <p:cNvPr id="30" name="Checks text"/>
+              <a:t>MAIN RESULT</a:t>
+            </a:r>
+          </a:p>
+        </p:txBody>
+      </p:sp>
+      <p:sp>
+        <p:nvSpPr>
+          <p:cNvPr id="33" name="Example stamp"/>
           <p:cNvSpPr txBox="1"/>
           <p:nvPr/>
         </p:nvSpPr>
         <p:spPr>
           <a:xfrm>
-            <a:off x="13258800" y="26837640"/>
-            <a:ext cx="17373600" cy="4709160"/>
+            <a:off x="15727680" y="5230367"/>
+            <a:ext cx="7269480" cy="411480"/>
           </a:xfrm>
           <a:prstGeom prst="rect">
             <a:avLst/>
@@ -4976,90 +5168,151 @@
           <a:p>
             <a:pPr algn="l">
               <a:spcAft>
-                <a:spcPts val="1000"/>
+                <a:spcPts val="0"/>
               </a:spcAft>
             </a:pPr>
             <a:r>
-              <a:rPr sz="2600" b="1" i="0">
-                <a:solidFill>
-                  <a:srgbClr val="000000"/>
-                </a:solidFill>
-                <a:latin typeface="Arial"/>
-              </a:rPr>
-              <a:t>Analysis:</a:t>
-            </a:r>
-            <a:r>
-              <a:rPr sz="2600" b="0" i="0">
-                <a:solidFill>
-                  <a:srgbClr val="000000"/>
-                </a:solidFill>
-                <a:latin typeface="Arial"/>
-              </a:rPr>
-              <a:t> what you declared before seeing results and why it fits your design; any later change, and why.</a:t>
-            </a:r>
-          </a:p>
+              <a:rPr sz="1500" b="1" i="0">
+                <a:solidFill>
+                  <a:srgbClr val="8A1C2B"/>
+                </a:solidFill>
+                <a:latin typeface="Arial"/>
+              </a:rPr>
+              <a:t>EXAMPLE · replace with your notebook's figure and its alt text</a:t>
+            </a:r>
+          </a:p>
+        </p:txBody>
+      </p:sp>
+      <p:pic>
+        <p:nvPicPr>
+          <p:cNvPr id="34" name="Example figure (replace)" descr="Simulated example. Top: mean checkout completion rate by version, A about 71 percent and B about 74 percent, each with a 95 percent interval of about plus or minus 4 points. Bottom: the difference, B minus A, 3.2 points, with a 95 percent interval from −2.5 to 9.0 points that crosses zero."/>
+          <p:cNvPicPr>
+            <a:picLocks noChangeAspect="1"/>
+          </p:cNvPicPr>
+          <p:nvPr/>
+        </p:nvPicPr>
+        <p:blipFill>
+          <a:blip r:embed="rId5"/>
+          <a:stretch>
+            <a:fillRect/>
+          </a:stretch>
+        </p:blipFill>
+        <p:spPr>
+          <a:xfrm>
+            <a:off x="15727680" y="5669279"/>
+            <a:ext cx="7269480" cy="8359902"/>
+          </a:xfrm>
+          <a:prstGeom prst="rect">
+            <a:avLst/>
+          </a:prstGeom>
+        </p:spPr>
+      </p:pic>
+      <p:sp>
+        <p:nvSpPr>
+          <p:cNvPr id="35" name="Figure caption"/>
+          <p:cNvSpPr txBox="1"/>
+          <p:nvPr/>
+        </p:nvSpPr>
+        <p:spPr>
+          <a:xfrm>
+            <a:off x="15727680" y="14074902"/>
+            <a:ext cx="7269480" cy="1188720"/>
+          </a:xfrm>
+          <a:prstGeom prst="rect">
+            <a:avLst/>
+          </a:prstGeom>
+          <a:noFill/>
+        </p:spPr>
+        <p:txBody>
+          <a:bodyPr wrap="square" anchor="t" lIns="109728" rIns="109728" tIns="109728" bIns="109728">
+            <a:noAutofit/>
+          </a:bodyPr>
+          <a:lstStyle/>
           <a:p>
             <a:pPr algn="l">
               <a:spcAft>
-                <a:spcPts val="1000"/>
+                <a:spcPts val="700"/>
               </a:spcAft>
             </a:pPr>
             <a:r>
-              <a:rPr sz="2600" b="1" i="0">
+              <a:rPr sz="1400" b="1" i="0">
                 <a:solidFill>
                   <a:srgbClr val="000000"/>
                 </a:solidFill>
                 <a:latin typeface="Arial"/>
               </a:rPr>
-              <a:t>Uncertainty:</a:t>
-            </a:r>
-            <a:r>
-              <a:rPr sz="2600" b="0" i="0">
+              <a:t>Fig. 1.</a:t>
+            </a:r>
+            <a:r>
+              <a:rPr sz="1400" b="0" i="0">
                 <a:solidFill>
                   <a:srgbClr val="000000"/>
                 </a:solidFill>
                 <a:latin typeface="Arial"/>
               </a:rPr>
-              <a:t> how you computed it, at the level of your independent unit, with any dependence named.</a:t>
-            </a:r>
-          </a:p>
+              <a:t> What it shows and for which units; n; the interval's type and level; bars start at zero. Source: [notebook], cell [N]. Panel (b) is the comparison the headline is about.</a:t>
+            </a:r>
+          </a:p>
+        </p:txBody>
+      </p:sp>
+      <p:sp>
+        <p:nvSpPr>
+          <p:cNvPr id="36" name="Result text"/>
+          <p:cNvSpPr txBox="1"/>
+          <p:nvPr/>
+        </p:nvSpPr>
+        <p:spPr>
+          <a:xfrm>
+            <a:off x="15727680" y="15217901"/>
+            <a:ext cx="7269480" cy="1012698"/>
+          </a:xfrm>
+          <a:prstGeom prst="rect">
+            <a:avLst/>
+          </a:prstGeom>
+          <a:noFill/>
+        </p:spPr>
+        <p:txBody>
+          <a:bodyPr wrap="square" anchor="t" lIns="109728" rIns="109728" tIns="109728" bIns="109728">
+            <a:noAutofit/>
+          </a:bodyPr>
+          <a:lstStyle/>
           <a:p>
             <a:pPr algn="l">
               <a:spcAft>
-                <a:spcPts val="1000"/>
+                <a:spcPts val="700"/>
               </a:spcAft>
             </a:pPr>
             <a:r>
-              <a:rPr sz="2600" b="1" i="0">
+              <a:rPr sz="1800" b="1" i="0">
                 <a:solidFill>
                   <a:srgbClr val="000000"/>
                 </a:solidFill>
                 <a:latin typeface="Arial"/>
               </a:rPr>
-              <a:t>One check:</a:t>
-            </a:r>
-            <a:r>
-              <a:rPr sz="2600" b="0" i="0">
+              <a:t>The result,</a:t>
+            </a:r>
+            <a:r>
+              <a:rPr sz="1800" b="0" i="0">
                 <a:solidFill>
                   <a:srgbClr val="000000"/>
                 </a:solidFill>
                 <a:latin typeface="Arial"/>
               </a:rPr>
-              <a:t> a robustness, sensitivity, or diagnostic check, and what it changed.</a:t>
-            </a:r>
-          </a:p>
-        </p:txBody>
-      </p:sp>
-      <p:sp>
-        <p:nvSpPr>
-          <p:cNvPr id="31" name="Heading: WHAT IT MEANS, AND WHERE IT STOPS"/>
+              <a:t> in numbers, units, and the uncertainty it warrants, in the words your boundary allows.</a:t>
+            </a:r>
+          </a:p>
+        </p:txBody>
+      </p:sp>
+      <p:sp>
+        <p:nvSpPr>
+          <p:cNvPr id="37" name="Heading: CHECKS AND VERIFICATION"/>
           <p:cNvSpPr/>
           <p:nvPr/>
         </p:nvSpPr>
         <p:spPr>
           <a:xfrm>
-            <a:off x="31318200" y="7315200"/>
-            <a:ext cx="11887200" cy="868680"/>
+            <a:off x="15727680" y="16322040"/>
+            <a:ext cx="7269480" cy="548640"/>
           </a:xfrm>
           <a:prstGeom prst="rect">
             <a:avLst/>
@@ -5087,7 +5340,7 @@
           </a:fontRef>
         </p:style>
         <p:txBody>
-          <a:bodyPr rtlCol="0" anchor="ctr" wrap="square" lIns="274320" rIns="274320" tIns="274320" bIns="274320">
+          <a:bodyPr rtlCol="0" anchor="ctr" wrap="square" lIns="182880" rIns="182880" tIns="182880" bIns="182880">
             <a:noAutofit/>
           </a:bodyPr>
           <a:lstStyle/>
@@ -5098,27 +5351,159 @@
               </a:spcAft>
             </a:pPr>
             <a:r>
-              <a:rPr sz="3200" b="1" i="0">
+              <a:rPr sz="2400" b="1" i="0">
                 <a:solidFill>
                   <a:srgbClr val="CFB991"/>
                 </a:solidFill>
                 <a:latin typeface="Arial"/>
               </a:rPr>
-              <a:t>WHAT IT MEANS, AND WHERE IT STOPS</a:t>
-            </a:r>
-          </a:p>
-        </p:txBody>
-      </p:sp>
-      <p:sp>
-        <p:nvSpPr>
-          <p:cNvPr id="32" name="Boundary: THIS EVIDENCE SUPPORTS"/>
+              <a:t>CHECKS AND VERIFICATION</a:t>
+            </a:r>
+          </a:p>
+        </p:txBody>
+      </p:sp>
+      <p:sp>
+        <p:nvSpPr>
+          <p:cNvPr id="38" name="Checks text"/>
+          <p:cNvSpPr txBox="1"/>
+          <p:nvPr/>
+        </p:nvSpPr>
+        <p:spPr>
+          <a:xfrm>
+            <a:off x="15727680" y="16916400"/>
+            <a:ext cx="7269480" cy="2926079"/>
+          </a:xfrm>
+          <a:prstGeom prst="rect">
+            <a:avLst/>
+          </a:prstGeom>
+          <a:noFill/>
+        </p:spPr>
+        <p:txBody>
+          <a:bodyPr wrap="square" anchor="t" lIns="109728" rIns="109728" tIns="109728" bIns="109728">
+            <a:noAutofit/>
+          </a:bodyPr>
+          <a:lstStyle/>
+          <a:p>
+            <a:pPr algn="l">
+              <a:spcAft>
+                <a:spcPts val="700"/>
+              </a:spcAft>
+            </a:pPr>
+            <a:r>
+              <a:rPr sz="1800" b="1" i="0">
+                <a:solidFill>
+                  <a:srgbClr val="000000"/>
+                </a:solidFill>
+                <a:latin typeface="Arial"/>
+              </a:rPr>
+              <a:t>One check:</a:t>
+            </a:r>
+            <a:r>
+              <a:rPr sz="1800" b="0" i="0">
+                <a:solidFill>
+                  <a:srgbClr val="000000"/>
+                </a:solidFill>
+                <a:latin typeface="Arial"/>
+              </a:rPr>
+              <a:t> a robustness, sensitivity, or diagnostic check, and what it changed.</a:t>
+            </a:r>
+          </a:p>
+          <a:p>
+            <a:pPr algn="l">
+              <a:spcAft>
+                <a:spcPts val="700"/>
+              </a:spcAft>
+            </a:pPr>
+            <a:r>
+              <a:rPr sz="1800" b="1" i="0">
+                <a:solidFill>
+                  <a:srgbClr val="000000"/>
+                </a:solidFill>
+                <a:latin typeface="Arial"/>
+              </a:rPr>
+              <a:t>Verification:</a:t>
+            </a:r>
+            <a:r>
+              <a:rPr sz="1800" b="0" i="0">
+                <a:solidFill>
+                  <a:srgbClr val="000000"/>
+                </a:solidFill>
+                <a:latin typeface="Arial"/>
+              </a:rPr>
+              <a:t> what was reproduced from your package, by whom, when; label a solo rerun “solo proxy; external cold run pending”.</a:t>
+            </a:r>
+          </a:p>
+        </p:txBody>
+      </p:sp>
+      <p:sp>
+        <p:nvSpPr>
+          <p:cNvPr id="39" name="Heading: CONCLUSIONS"/>
           <p:cNvSpPr/>
           <p:nvPr/>
         </p:nvSpPr>
         <p:spPr>
           <a:xfrm>
-            <a:off x="31318200" y="8366759"/>
-            <a:ext cx="11887200" cy="2103120"/>
+            <a:off x="23362919" y="4663440"/>
+            <a:ext cx="7269480" cy="548640"/>
+          </a:xfrm>
+          <a:prstGeom prst="rect">
+            <a:avLst/>
+          </a:prstGeom>
+          <a:solidFill>
+            <a:srgbClr val="000000"/>
+          </a:solidFill>
+          <a:ln>
+            <a:noFill/>
+          </a:ln>
+          <a:effectLst/>
+        </p:spPr>
+        <p:style>
+          <a:lnRef idx="1">
+            <a:schemeClr val="accent1"/>
+          </a:lnRef>
+          <a:fillRef idx="3">
+            <a:schemeClr val="accent1"/>
+          </a:fillRef>
+          <a:effectRef idx="2">
+            <a:schemeClr val="accent1"/>
+          </a:effectRef>
+          <a:fontRef idx="minor">
+            <a:schemeClr val="lt1"/>
+          </a:fontRef>
+        </p:style>
+        <p:txBody>
+          <a:bodyPr rtlCol="0" anchor="ctr" wrap="square" lIns="182880" rIns="182880" tIns="182880" bIns="182880">
+            <a:noAutofit/>
+          </a:bodyPr>
+          <a:lstStyle/>
+          <a:p>
+            <a:pPr algn="l">
+              <a:spcAft>
+                <a:spcPts val="0"/>
+              </a:spcAft>
+            </a:pPr>
+            <a:r>
+              <a:rPr sz="2400" b="1" i="0">
+                <a:solidFill>
+                  <a:srgbClr val="CFB991"/>
+                </a:solidFill>
+                <a:latin typeface="Arial"/>
+              </a:rPr>
+              <a:t>CONCLUSIONS</a:t>
+            </a:r>
+          </a:p>
+        </p:txBody>
+      </p:sp>
+      <p:sp>
+        <p:nvSpPr>
+          <p:cNvPr id="40" name="Conclusion: THIS EVIDENCE SUPPORTS"/>
+          <p:cNvSpPr/>
+          <p:nvPr/>
+        </p:nvSpPr>
+        <p:spPr>
+          <a:xfrm>
+            <a:off x="23362919" y="5303519"/>
+            <a:ext cx="3566160" cy="1417320"/>
           </a:xfrm>
           <a:prstGeom prst="rect">
             <a:avLst/>
@@ -5148,18 +5533,18 @@
           </a:fontRef>
         </p:style>
         <p:txBody>
-          <a:bodyPr rtlCol="0" anchor="t" wrap="square" lIns="182880" rIns="182880" tIns="182880" bIns="182880">
+          <a:bodyPr rtlCol="0" anchor="t" wrap="square" tIns="91440" bIns="91440">
             <a:noAutofit/>
           </a:bodyPr>
           <a:lstStyle/>
           <a:p>
             <a:pPr algn="l">
               <a:spcAft>
-                <a:spcPts val="400"/>
+                <a:spcPts val="200"/>
               </a:spcAft>
             </a:pPr>
             <a:r>
-              <a:rPr sz="2200" b="1" i="0">
+              <a:rPr sz="1400" b="1" i="0">
                 <a:solidFill>
                   <a:srgbClr val="000000"/>
                 </a:solidFill>
@@ -5175,27 +5560,27 @@
               </a:spcAft>
             </a:pPr>
             <a:r>
-              <a:rPr sz="2400" b="0" i="0">
+              <a:rPr sz="1800" b="0" i="0">
                 <a:solidFill>
                   <a:srgbClr val="000000"/>
                 </a:solidFill>
                 <a:latin typeface="Arial"/>
               </a:rPr>
-              <a:t>[your claim, with its verb and its population]</a:t>
-            </a:r>
-          </a:p>
-        </p:txBody>
-      </p:sp>
-      <p:sp>
-        <p:nvSpPr>
-          <p:cNvPr id="33" name="Boundary: IT DOES NOT YET SUPPORT"/>
+              <a:t>[your claim, its verb, its population]</a:t>
+            </a:r>
+          </a:p>
+        </p:txBody>
+      </p:sp>
+      <p:sp>
+        <p:nvSpPr>
+          <p:cNvPr id="41" name="Conclusion: IT DOES NOT YET SUPPORT"/>
           <p:cNvSpPr/>
           <p:nvPr/>
         </p:nvSpPr>
         <p:spPr>
           <a:xfrm>
-            <a:off x="31318200" y="10607039"/>
-            <a:ext cx="11887200" cy="2103120"/>
+            <a:off x="27066239" y="5303519"/>
+            <a:ext cx="3566160" cy="1417320"/>
           </a:xfrm>
           <a:prstGeom prst="rect">
             <a:avLst/>
@@ -5225,18 +5610,18 @@
           </a:fontRef>
         </p:style>
         <p:txBody>
-          <a:bodyPr rtlCol="0" anchor="t" wrap="square" lIns="182880" rIns="182880" tIns="182880" bIns="182880">
+          <a:bodyPr rtlCol="0" anchor="t" wrap="square" tIns="91440" bIns="91440">
             <a:noAutofit/>
           </a:bodyPr>
           <a:lstStyle/>
           <a:p>
             <a:pPr algn="l">
               <a:spcAft>
-                <a:spcPts val="400"/>
+                <a:spcPts val="200"/>
               </a:spcAft>
             </a:pPr>
             <a:r>
-              <a:rPr sz="2200" b="1" i="0">
+              <a:rPr sz="1400" b="1" i="0">
                 <a:solidFill>
                   <a:srgbClr val="000000"/>
                 </a:solidFill>
@@ -5252,27 +5637,27 @@
               </a:spcAft>
             </a:pPr>
             <a:r>
-              <a:rPr sz="2400" b="0" i="0">
+              <a:rPr sz="1800" b="0" i="0">
                 <a:solidFill>
                   <a:srgbClr val="000000"/>
                 </a:solidFill>
                 <a:latin typeface="Arial"/>
               </a:rPr>
-              <a:t>[the larger claim a visitor might infer: a cause, a wider population, a longer time]</a:t>
-            </a:r>
-          </a:p>
-        </p:txBody>
-      </p:sp>
-      <p:sp>
-        <p:nvSpPr>
-          <p:cNvPr id="34" name="Meaning and ULN text"/>
+              <a:t>[a cause? a wider population?]</a:t>
+            </a:r>
+          </a:p>
+        </p:txBody>
+      </p:sp>
+      <p:sp>
+        <p:nvSpPr>
+          <p:cNvPr id="42" name="Conclusions text"/>
           <p:cNvSpPr txBox="1"/>
           <p:nvPr/>
         </p:nvSpPr>
         <p:spPr>
           <a:xfrm>
-            <a:off x="31318200" y="12984480"/>
-            <a:ext cx="11887200" cy="6903720"/>
+            <a:off x="23362919" y="6812279"/>
+            <a:ext cx="7269480" cy="1828800"/>
           </a:xfrm>
           <a:prstGeom prst="rect">
             <a:avLst/>
@@ -5287,115 +5672,31 @@
           <a:p>
             <a:pPr algn="l">
               <a:spcAft>
-                <a:spcPts val="1000"/>
+                <a:spcPts val="700"/>
               </a:spcAft>
             </a:pPr>
             <a:r>
-              <a:rPr sz="2600" b="1" i="0">
+              <a:rPr sz="1800" b="0" i="0">
                 <a:solidFill>
                   <a:srgbClr val="000000"/>
                 </a:solidFill>
                 <a:latin typeface="Arial"/>
               </a:rPr>
-              <a:t>Answer:</a:t>
-            </a:r>
-            <a:r>
-              <a:rPr sz="2600" b="0" i="0">
-                <a:solidFill>
-                  <a:srgbClr val="000000"/>
-                </a:solidFill>
-                <a:latin typeface="Arial"/>
-              </a:rPr>
-              <a:t> your question, in one sentence, no more strongly than the evidence allows.</a:t>
-            </a:r>
-          </a:p>
-          <a:p>
-            <a:pPr algn="l">
-              <a:spcAft>
-                <a:spcPts val="1000"/>
-              </a:spcAft>
-            </a:pPr>
-            <a:r>
-              <a:rPr sz="2600" b="1" i="0">
-                <a:solidFill>
-                  <a:srgbClr val="000000"/>
-                </a:solidFill>
-                <a:latin typeface="Arial"/>
-              </a:rPr>
-              <a:t>Uncertainty:</a:t>
-            </a:r>
-            <a:r>
-              <a:rPr sz="2600" b="0" i="0">
-                <a:solidFill>
-                  <a:srgbClr val="000000"/>
-                </a:solidFill>
-                <a:latin typeface="Arial"/>
-              </a:rPr>
-              <a:t> how far the estimate could move.</a:t>
-            </a:r>
-          </a:p>
-          <a:p>
-            <a:pPr algn="l">
-              <a:spcAft>
-                <a:spcPts val="1000"/>
-              </a:spcAft>
-            </a:pPr>
-            <a:r>
-              <a:rPr sz="2600" b="1" i="0">
-                <a:solidFill>
-                  <a:srgbClr val="000000"/>
-                </a:solidFill>
-                <a:latin typeface="Arial"/>
-              </a:rPr>
-              <a:t>Limitation:</a:t>
-            </a:r>
-            <a:r>
-              <a:rPr sz="2600" b="0" i="0">
-                <a:solidFill>
-                  <a:srgbClr val="000000"/>
-                </a:solidFill>
-                <a:latin typeface="Arial"/>
-              </a:rPr>
-              <a:t> the one most likely to change the finding.</a:t>
-            </a:r>
-          </a:p>
-          <a:p>
-            <a:pPr algn="l">
-              <a:spcAft>
-                <a:spcPts val="1000"/>
-              </a:spcAft>
-            </a:pPr>
-            <a:r>
-              <a:rPr sz="2600" b="1" i="0">
-                <a:solidFill>
-                  <a:srgbClr val="000000"/>
-                </a:solidFill>
-                <a:latin typeface="Arial"/>
-              </a:rPr>
-              <a:t>Next step:</a:t>
-            </a:r>
-            <a:r>
-              <a:rPr sz="2600" b="0" i="0">
-                <a:solidFill>
-                  <a:srgbClr val="000000"/>
-                </a:solidFill>
-                <a:latin typeface="Arial"/>
-              </a:rPr>
-              <a:t> the study that would settle it.</a:t>
-            </a:r>
-          </a:p>
-        </p:txBody>
-      </p:sp>
-      <p:sp>
-        <p:nvSpPr>
-          <p:cNvPr id="35" name="Heading: SOURCES, AI USE, AND CREDITS"/>
+              <a:t>Answer your question in one or two sentences, no more strongly than the evidence allows, and say what it means for the stakeholder.</a:t>
+            </a:r>
+          </a:p>
+        </p:txBody>
+      </p:sp>
+      <p:sp>
+        <p:nvSpPr>
+          <p:cNvPr id="43" name="Heading: LIMITATIONS"/>
           <p:cNvSpPr/>
           <p:nvPr/>
         </p:nvSpPr>
         <p:spPr>
           <a:xfrm>
-            <a:off x="31318200" y="20162520"/>
-            <a:ext cx="11887200" cy="868680"/>
+            <a:off x="23362919" y="9098280"/>
+            <a:ext cx="7269480" cy="548640"/>
           </a:xfrm>
           <a:prstGeom prst="rect">
             <a:avLst/>
@@ -5423,7 +5724,7 @@
           </a:fontRef>
         </p:style>
         <p:txBody>
-          <a:bodyPr rtlCol="0" anchor="ctr" wrap="square" lIns="274320" rIns="274320" tIns="274320" bIns="274320">
+          <a:bodyPr rtlCol="0" anchor="ctr" wrap="square" lIns="182880" rIns="182880" tIns="182880" bIns="182880">
             <a:noAutofit/>
           </a:bodyPr>
           <a:lstStyle/>
@@ -5434,27 +5735,27 @@
               </a:spcAft>
             </a:pPr>
             <a:r>
-              <a:rPr sz="3200" b="1" i="0">
+              <a:rPr sz="2400" b="1" i="0">
                 <a:solidFill>
                   <a:srgbClr val="CFB991"/>
                 </a:solidFill>
                 <a:latin typeface="Arial"/>
               </a:rPr>
-              <a:t>SOURCES, AI USE, AND CREDITS</a:t>
-            </a:r>
-          </a:p>
-        </p:txBody>
-      </p:sp>
-      <p:sp>
-        <p:nvSpPr>
-          <p:cNvPr id="36" name="AI disclosure"/>
+              <a:t>LIMITATIONS</a:t>
+            </a:r>
+          </a:p>
+        </p:txBody>
+      </p:sp>
+      <p:sp>
+        <p:nvSpPr>
+          <p:cNvPr id="44" name="Limitations text"/>
           <p:cNvSpPr txBox="1"/>
           <p:nvPr/>
         </p:nvSpPr>
         <p:spPr>
           <a:xfrm>
-            <a:off x="31318200" y="21122640"/>
-            <a:ext cx="11887200" cy="3931920"/>
+            <a:off x="23362919" y="9692640"/>
+            <a:ext cx="7269480" cy="2468880"/>
           </a:xfrm>
           <a:prstGeom prst="rect">
             <a:avLst/>
@@ -5469,72 +5770,149 @@
           <a:p>
             <a:pPr algn="l">
               <a:spcAft>
-                <a:spcPts val="1000"/>
+                <a:spcPts val="700"/>
               </a:spcAft>
             </a:pPr>
             <a:r>
-              <a:rPr sz="2400" b="1" i="0">
+              <a:rPr sz="1800" b="1" i="0">
                 <a:solidFill>
                   <a:srgbClr val="000000"/>
                 </a:solidFill>
                 <a:latin typeface="Arial"/>
               </a:rPr>
-              <a:t>AI use, on the poster itself.</a:t>
-            </a:r>
-            <a:r>
-              <a:rPr sz="2400" b="0" i="0">
+              <a:t>Uncertainty:</a:t>
+            </a:r>
+            <a:r>
+              <a:rPr sz="1800" b="0" i="0">
                 <a:solidFill>
                   <a:srgbClr val="000000"/>
                 </a:solidFill>
                 <a:latin typeface="Arial"/>
               </a:rPr>
-              <a:t> One line per tool:</a:t>
+              <a:t> how far the estimate could move.</a:t>
             </a:r>
           </a:p>
           <a:p>
             <a:pPr algn="l">
               <a:spcAft>
-                <a:spcPts val="1000"/>
+                <a:spcPts val="700"/>
               </a:spcAft>
             </a:pPr>
             <a:r>
-              <a:rPr sz="2400" b="0" i="1">
+              <a:rPr sz="1800" b="1" i="0">
                 <a:solidFill>
                   <a:srgbClr val="000000"/>
                 </a:solidFill>
                 <a:latin typeface="Arial"/>
               </a:rPr>
-              <a:t>[Tool]: used to [purpose]; I [changed / kept what]; I checked it by [method].</a:t>
+              <a:t>Limitation:</a:t>
+            </a:r>
+            <a:r>
+              <a:rPr sz="1800" b="0" i="0">
+                <a:solidFill>
+                  <a:srgbClr val="000000"/>
+                </a:solidFill>
+                <a:latin typeface="Arial"/>
+              </a:rPr>
+              <a:t> the one most likely to change the finding.</a:t>
             </a:r>
           </a:p>
           <a:p>
             <a:pPr algn="l">
               <a:spcAft>
-                <a:spcPts val="1000"/>
+                <a:spcPts val="700"/>
               </a:spcAft>
             </a:pPr>
             <a:r>
-              <a:rPr sz="2000" b="0" i="0">
-                <a:solidFill>
-                  <a:srgbClr val="404040"/>
-                </a:solidFill>
-                <a:latin typeface="Arial"/>
-              </a:rPr>
-              <a:t>Write “No AI used” only if that is true.</a:t>
-            </a:r>
-          </a:p>
-        </p:txBody>
-      </p:sp>
-      <p:sp>
-        <p:nvSpPr>
-          <p:cNvPr id="37" name="References text"/>
+              <a:rPr sz="1800" b="1" i="0">
+                <a:solidFill>
+                  <a:srgbClr val="000000"/>
+                </a:solidFill>
+                <a:latin typeface="Arial"/>
+              </a:rPr>
+              <a:t>Next step:</a:t>
+            </a:r>
+            <a:r>
+              <a:rPr sz="1800" b="0" i="0">
+                <a:solidFill>
+                  <a:srgbClr val="000000"/>
+                </a:solidFill>
+                <a:latin typeface="Arial"/>
+              </a:rPr>
+              <a:t> the study that would settle it.</a:t>
+            </a:r>
+          </a:p>
+        </p:txBody>
+      </p:sp>
+      <p:sp>
+        <p:nvSpPr>
+          <p:cNvPr id="45" name="Heading: AI USE DISCLOSURE"/>
+          <p:cNvSpPr/>
+          <p:nvPr/>
+        </p:nvSpPr>
+        <p:spPr>
+          <a:xfrm>
+            <a:off x="23362919" y="12664440"/>
+            <a:ext cx="7269480" cy="548640"/>
+          </a:xfrm>
+          <a:prstGeom prst="rect">
+            <a:avLst/>
+          </a:prstGeom>
+          <a:solidFill>
+            <a:srgbClr val="000000"/>
+          </a:solidFill>
+          <a:ln>
+            <a:noFill/>
+          </a:ln>
+          <a:effectLst/>
+        </p:spPr>
+        <p:style>
+          <a:lnRef idx="1">
+            <a:schemeClr val="accent1"/>
+          </a:lnRef>
+          <a:fillRef idx="3">
+            <a:schemeClr val="accent1"/>
+          </a:fillRef>
+          <a:effectRef idx="2">
+            <a:schemeClr val="accent1"/>
+          </a:effectRef>
+          <a:fontRef idx="minor">
+            <a:schemeClr val="lt1"/>
+          </a:fontRef>
+        </p:style>
+        <p:txBody>
+          <a:bodyPr rtlCol="0" anchor="ctr" wrap="square" lIns="182880" rIns="182880" tIns="182880" bIns="182880">
+            <a:noAutofit/>
+          </a:bodyPr>
+          <a:lstStyle/>
+          <a:p>
+            <a:pPr algn="l">
+              <a:spcAft>
+                <a:spcPts val="0"/>
+              </a:spcAft>
+            </a:pPr>
+            <a:r>
+              <a:rPr sz="2400" b="1" i="0">
+                <a:solidFill>
+                  <a:srgbClr val="CFB991"/>
+                </a:solidFill>
+                <a:latin typeface="Arial"/>
+              </a:rPr>
+              <a:t>AI USE DISCLOSURE</a:t>
+            </a:r>
+          </a:p>
+        </p:txBody>
+      </p:sp>
+      <p:sp>
+        <p:nvSpPr>
+          <p:cNvPr id="46" name="AI disclosure"/>
           <p:cNvSpPr txBox="1"/>
           <p:nvPr/>
         </p:nvSpPr>
         <p:spPr>
           <a:xfrm>
-            <a:off x="31318200" y="25146000"/>
-            <a:ext cx="11887200" cy="3017520"/>
+            <a:off x="23362919" y="13258800"/>
+            <a:ext cx="7269480" cy="1828800"/>
           </a:xfrm>
           <a:prstGeom prst="rect">
             <a:avLst/>
@@ -5549,40 +5927,115 @@
           <a:p>
             <a:pPr algn="l">
               <a:spcAft>
-                <a:spcPts val="1000"/>
+                <a:spcPts val="700"/>
               </a:spcAft>
             </a:pPr>
             <a:r>
-              <a:rPr sz="2000" b="1" i="0">
+              <a:rPr sz="1800" b="0" i="0">
                 <a:solidFill>
                   <a:srgbClr val="000000"/>
                 </a:solidFill>
                 <a:latin typeface="Arial"/>
               </a:rPr>
-              <a:t>References.</a:t>
-            </a:r>
-            <a:r>
-              <a:rPr sz="2000" b="0" i="0">
+              <a:t>One line per tool, on the poster: </a:t>
+            </a:r>
+            <a:r>
+              <a:rPr sz="1800" b="0" i="1">
                 <a:solidFill>
                   <a:srgbClr val="000000"/>
                 </a:solidFill>
                 <a:latin typeface="Arial"/>
               </a:rPr>
-              <a:t> Three to six sources you opened yourself: Author (Year). Title. Venue. DOI or URL.</a:t>
-            </a:r>
-          </a:p>
-        </p:txBody>
-      </p:sp>
-      <p:sp>
-        <p:nvSpPr>
-          <p:cNvPr id="38" name="Acknowledgments text"/>
+              <a:t>[Tool]: used to [purpose]; I [changed / kept what]; I checked it by [method].</a:t>
+            </a:r>
+          </a:p>
+          <a:p>
+            <a:pPr algn="l">
+              <a:spcAft>
+                <a:spcPts val="700"/>
+              </a:spcAft>
+            </a:pPr>
+            <a:r>
+              <a:rPr sz="1400" b="0" i="0">
+                <a:solidFill>
+                  <a:srgbClr val="404040"/>
+                </a:solidFill>
+                <a:latin typeface="Arial"/>
+              </a:rPr>
+              <a:t>Write “No AI used” only if that is true.</a:t>
+            </a:r>
+          </a:p>
+        </p:txBody>
+      </p:sp>
+      <p:sp>
+        <p:nvSpPr>
+          <p:cNvPr id="47" name="Heading: REFERENCES"/>
+          <p:cNvSpPr/>
+          <p:nvPr/>
+        </p:nvSpPr>
+        <p:spPr>
+          <a:xfrm>
+            <a:off x="23362919" y="15179040"/>
+            <a:ext cx="7269480" cy="548640"/>
+          </a:xfrm>
+          <a:prstGeom prst="rect">
+            <a:avLst/>
+          </a:prstGeom>
+          <a:solidFill>
+            <a:srgbClr val="000000"/>
+          </a:solidFill>
+          <a:ln>
+            <a:noFill/>
+          </a:ln>
+          <a:effectLst/>
+        </p:spPr>
+        <p:style>
+          <a:lnRef idx="1">
+            <a:schemeClr val="accent1"/>
+          </a:lnRef>
+          <a:fillRef idx="3">
+            <a:schemeClr val="accent1"/>
+          </a:fillRef>
+          <a:effectRef idx="2">
+            <a:schemeClr val="accent1"/>
+          </a:effectRef>
+          <a:fontRef idx="minor">
+            <a:schemeClr val="lt1"/>
+          </a:fontRef>
+        </p:style>
+        <p:txBody>
+          <a:bodyPr rtlCol="0" anchor="ctr" wrap="square" lIns="182880" rIns="182880" tIns="182880" bIns="182880">
+            <a:noAutofit/>
+          </a:bodyPr>
+          <a:lstStyle/>
+          <a:p>
+            <a:pPr algn="l">
+              <a:spcAft>
+                <a:spcPts val="0"/>
+              </a:spcAft>
+            </a:pPr>
+            <a:r>
+              <a:rPr sz="2400" b="1" i="0">
+                <a:solidFill>
+                  <a:srgbClr val="CFB991"/>
+                </a:solidFill>
+                <a:latin typeface="Arial"/>
+              </a:rPr>
+              <a:t>REFERENCES</a:t>
+            </a:r>
+          </a:p>
+        </p:txBody>
+      </p:sp>
+      <p:sp>
+        <p:nvSpPr>
+          <p:cNvPr id="48" name="References text"/>
           <p:cNvSpPr txBox="1"/>
           <p:nvPr/>
         </p:nvSpPr>
         <p:spPr>
           <a:xfrm>
-            <a:off x="31318200" y="28254960"/>
-            <a:ext cx="9372600" cy="3291839"/>
+            <a:off x="23362919" y="15773400"/>
+            <a:ext cx="7269480" cy="1691640"/>
           </a:xfrm>
           <a:prstGeom prst="rect">
             <a:avLst/>
@@ -5597,40 +6050,129 @@
           <a:p>
             <a:pPr algn="l">
               <a:spcAft>
-                <a:spcPts val="1000"/>
+                <a:spcPts val="700"/>
               </a:spcAft>
             </a:pPr>
             <a:r>
-              <a:rPr sz="1800" b="1" i="0">
+              <a:rPr sz="1400" b="0" i="0">
                 <a:solidFill>
                   <a:srgbClr val="000000"/>
                 </a:solidFill>
                 <a:latin typeface="Arial"/>
               </a:rPr>
-              <a:t>Acknowledgments.</a:t>
-            </a:r>
-            <a:r>
-              <a:rPr sz="1800" b="0" i="0">
-                <a:solidFill>
-                  <a:srgbClr val="000000"/>
-                </a:solidFill>
-                <a:latin typeface="Arial"/>
-              </a:rPr>
-              <a:t> I thank Professor Davi Moreira for mentoring this project, and the John Martinson Honors College and the Office of Undergraduate Research for the chance to present it. [Thank any data provider, participants, or funder.]</a:t>
-            </a:r>
-          </a:p>
-        </p:txBody>
-      </p:sp>
-      <p:sp>
-        <p:nvSpPr>
-          <p:cNvPr id="39" name="QR code placeholder"/>
+              <a:t>Three to six sources you opened yourself. Author (Year). Title. Venue. DOI or URL.</a:t>
+            </a:r>
+          </a:p>
+        </p:txBody>
+      </p:sp>
+      <p:sp>
+        <p:nvSpPr>
+          <p:cNvPr id="49" name="Heading: ACKNOWLEDGMENTS"/>
           <p:cNvSpPr/>
           <p:nvPr/>
         </p:nvSpPr>
         <p:spPr>
           <a:xfrm>
-            <a:off x="40873680" y="28346400"/>
-            <a:ext cx="2331720" cy="2331720"/>
+            <a:off x="23362919" y="17602200"/>
+            <a:ext cx="7269480" cy="548640"/>
+          </a:xfrm>
+          <a:prstGeom prst="rect">
+            <a:avLst/>
+          </a:prstGeom>
+          <a:solidFill>
+            <a:srgbClr val="000000"/>
+          </a:solidFill>
+          <a:ln>
+            <a:noFill/>
+          </a:ln>
+          <a:effectLst/>
+        </p:spPr>
+        <p:style>
+          <a:lnRef idx="1">
+            <a:schemeClr val="accent1"/>
+          </a:lnRef>
+          <a:fillRef idx="3">
+            <a:schemeClr val="accent1"/>
+          </a:fillRef>
+          <a:effectRef idx="2">
+            <a:schemeClr val="accent1"/>
+          </a:effectRef>
+          <a:fontRef idx="minor">
+            <a:schemeClr val="lt1"/>
+          </a:fontRef>
+        </p:style>
+        <p:txBody>
+          <a:bodyPr rtlCol="0" anchor="ctr" wrap="square" lIns="182880" rIns="182880" tIns="182880" bIns="182880">
+            <a:noAutofit/>
+          </a:bodyPr>
+          <a:lstStyle/>
+          <a:p>
+            <a:pPr algn="l">
+              <a:spcAft>
+                <a:spcPts val="0"/>
+              </a:spcAft>
+            </a:pPr>
+            <a:r>
+              <a:rPr sz="2400" b="1" i="0">
+                <a:solidFill>
+                  <a:srgbClr val="CFB991"/>
+                </a:solidFill>
+                <a:latin typeface="Arial"/>
+              </a:rPr>
+              <a:t>ACKNOWLEDGMENTS</a:t>
+            </a:r>
+          </a:p>
+        </p:txBody>
+      </p:sp>
+      <p:sp>
+        <p:nvSpPr>
+          <p:cNvPr id="50" name="Acknowledgments text"/>
+          <p:cNvSpPr txBox="1"/>
+          <p:nvPr/>
+        </p:nvSpPr>
+        <p:spPr>
+          <a:xfrm>
+            <a:off x="23362919" y="18196560"/>
+            <a:ext cx="5943600" cy="1645919"/>
+          </a:xfrm>
+          <a:prstGeom prst="rect">
+            <a:avLst/>
+          </a:prstGeom>
+          <a:noFill/>
+        </p:spPr>
+        <p:txBody>
+          <a:bodyPr wrap="square" anchor="t" lIns="109728" rIns="109728" tIns="109728" bIns="109728">
+            <a:noAutofit/>
+          </a:bodyPr>
+          <a:lstStyle/>
+          <a:p>
+            <a:pPr algn="l">
+              <a:spcAft>
+                <a:spcPts val="700"/>
+              </a:spcAft>
+            </a:pPr>
+            <a:r>
+              <a:rPr sz="1400" b="0" i="0">
+                <a:solidFill>
+                  <a:srgbClr val="000000"/>
+                </a:solidFill>
+                <a:latin typeface="Arial"/>
+              </a:rPr>
+              <a:t>I thank Professor Davi Moreira for mentoring this project, and the John Martinson Honors College and the Office of Undergraduate Research for the chance to present it. [Thank any data provider, participants, or funder.]</a:t>
+            </a:r>
+          </a:p>
+        </p:txBody>
+      </p:sp>
+      <p:sp>
+        <p:nvSpPr>
+          <p:cNvPr id="51" name="QR code placeholder"/>
+          <p:cNvSpPr/>
+          <p:nvPr/>
+        </p:nvSpPr>
+        <p:spPr>
+          <a:xfrm>
+            <a:off x="29397960" y="18242280"/>
+            <a:ext cx="1234440" cy="1234440"/>
           </a:xfrm>
           <a:prstGeom prst="rect">
             <a:avLst/>
@@ -5672,27 +6214,27 @@
               </a:spcAft>
             </a:pPr>
             <a:r>
-              <a:rPr sz="1600" b="0" i="0">
+              <a:rPr sz="1200" b="0" i="0">
                 <a:solidFill>
                   <a:srgbClr val="404040"/>
                 </a:solidFill>
                 <a:latin typeface="Arial"/>
               </a:rPr>
-              <a:t>Optional QR + short URL: a text version of this poster</a:t>
-            </a:r>
-          </a:p>
-        </p:txBody>
-      </p:sp>
-      <p:sp>
-        <p:nvSpPr>
-          <p:cNvPr id="40" name="Verification status line"/>
+              <a:t>Optional QR</a:t>
+            </a:r>
+          </a:p>
+        </p:txBody>
+      </p:sp>
+      <p:sp>
+        <p:nvSpPr>
+          <p:cNvPr id="52" name="Verification status line"/>
           <p:cNvSpPr txBox="1"/>
           <p:nvPr/>
         </p:nvSpPr>
         <p:spPr>
           <a:xfrm>
-            <a:off x="685800" y="31866840"/>
-            <a:ext cx="25146000" cy="777240"/>
+            <a:off x="457200" y="19979640"/>
+            <a:ext cx="16916400" cy="457200"/>
           </a:xfrm>
           <a:prstGeom prst="rect">
             <a:avLst/>
@@ -5711,27 +6253,27 @@
               </a:spcAft>
             </a:pPr>
             <a:r>
-              <a:rPr sz="1800" b="0" i="0">
+              <a:rPr sz="1300" b="0" i="0">
                 <a:solidFill>
                   <a:srgbClr val="404040"/>
                 </a:solidFill>
                 <a:latin typeface="Arial"/>
               </a:rPr>
-              <a:t>Verification status: [what has been checked, by whom, and when; what is still pending] · Poster version [N], [date]</a:t>
-            </a:r>
-          </a:p>
-        </p:txBody>
-      </p:sp>
-      <p:sp>
-        <p:nvSpPr>
-          <p:cNvPr id="41" name="Status line"/>
+              <a:t>Verification status: [what has been checked, by whom, and when; what is pending] · Poster version [N], [date]</a:t>
+            </a:r>
+          </a:p>
+        </p:txBody>
+      </p:sp>
+      <p:sp>
+        <p:nvSpPr>
+          <p:cNvPr id="53" name="Status line"/>
           <p:cNvSpPr txBox="1"/>
           <p:nvPr/>
         </p:nvSpPr>
         <p:spPr>
           <a:xfrm>
-            <a:off x="26060400" y="31866840"/>
-            <a:ext cx="17145000" cy="777240"/>
+            <a:off x="17830800" y="19979640"/>
+            <a:ext cx="12801600" cy="457200"/>
           </a:xfrm>
           <a:prstGeom prst="rect">
             <a:avLst/>
@@ -5750,7 +6292,7 @@
               </a:spcAft>
             </a:pPr>
             <a:r>
-              <a:rPr sz="1800" b="0" i="0">
+              <a:rPr sz="1300" b="0" i="0">
                 <a:solidFill>
                   <a:srgbClr val="404040"/>
                 </a:solidFill>
@@ -5787,8 +6329,8 @@
         </p:nvSpPr>
         <p:spPr>
           <a:xfrm>
-            <a:off x="685800" y="548640"/>
-            <a:ext cx="42519600" cy="2011680"/>
+            <a:off x="457200" y="365760"/>
+            <a:ext cx="30175200" cy="1463040"/>
           </a:xfrm>
           <a:prstGeom prst="rect">
             <a:avLst/>
@@ -5803,11 +6345,11 @@
           <a:p>
             <a:pPr algn="l">
               <a:spcAft>
-                <a:spcPts val="1000"/>
+                <a:spcPts val="700"/>
               </a:spcAft>
             </a:pPr>
             <a:r>
-              <a:rPr sz="7200" b="1" i="0">
+              <a:rPr sz="4800" b="1" i="0">
                 <a:solidFill>
                   <a:srgbClr val="000000"/>
                 </a:solidFill>
@@ -5819,11 +6361,11 @@
           <a:p>
             <a:pPr algn="l">
               <a:spcAft>
-                <a:spcPts val="1000"/>
+                <a:spcPts val="700"/>
               </a:spcAft>
             </a:pPr>
             <a:r>
-              <a:rPr sz="3400" b="1" i="0">
+              <a:rPr sz="2400" b="1" i="0">
                 <a:solidFill>
                   <a:srgbClr val="8A1C2B"/>
                 </a:solidFill>
@@ -5842,8 +6384,8 @@
         </p:nvSpPr>
         <p:spPr>
           <a:xfrm>
-            <a:off x="685800" y="3840480"/>
-            <a:ext cx="13563600" cy="868680"/>
+            <a:off x="457200" y="2377440"/>
+            <a:ext cx="9692640" cy="548640"/>
           </a:xfrm>
           <a:prstGeom prst="rect">
             <a:avLst/>
@@ -5871,7 +6413,7 @@
           </a:fontRef>
         </p:style>
         <p:txBody>
-          <a:bodyPr rtlCol="0" anchor="ctr" wrap="square" lIns="274320" rIns="274320" tIns="274320" bIns="274320">
+          <a:bodyPr rtlCol="0" anchor="ctr" wrap="square" lIns="182880" rIns="182880" tIns="182880" bIns="182880">
             <a:noAutofit/>
           </a:bodyPr>
           <a:lstStyle/>
@@ -5882,7 +6424,7 @@
               </a:spcAft>
             </a:pPr>
             <a:r>
-              <a:rPr sz="3400" b="1" i="0">
+              <a:rPr sz="2400" b="1" i="0">
                 <a:solidFill>
                   <a:srgbClr val="CFB991"/>
                 </a:solidFill>
@@ -5901,8 +6443,8 @@
         </p:nvSpPr>
         <p:spPr>
           <a:xfrm>
-            <a:off x="685800" y="4800600"/>
-            <a:ext cx="13563600" cy="16459200"/>
+            <a:off x="457200" y="3017520"/>
+            <a:ext cx="9692640" cy="15544800"/>
           </a:xfrm>
           <a:prstGeom prst="rect">
             <a:avLst/>
@@ -5917,11 +6459,11 @@
           <a:p>
             <a:pPr algn="l">
               <a:spcAft>
-                <a:spcPts val="1400"/>
+                <a:spcPts val="900"/>
               </a:spcAft>
             </a:pPr>
             <a:r>
-              <a:rPr sz="3400" b="1" i="0">
+              <a:rPr sz="2200" b="1" i="0">
                 <a:solidFill>
                   <a:srgbClr val="000000"/>
                 </a:solidFill>
@@ -5930,113 +6472,138 @@
               <a:t>Size:</a:t>
             </a:r>
             <a:r>
-              <a:rPr sz="3400" b="0" i="0">
+              <a:rPr sz="2200" b="0" i="0">
                 <a:solidFill>
                   <a:srgbClr val="000000"/>
                 </a:solidFill>
                 <a:latin typeface="Arial"/>
               </a:rPr>
-              <a:t> 48 × 36 in, landscape, the Expo's standard 4′ × 3′ board. Do not change the slide size.</a:t>
+              <a:t> 34 × 22.5 in, landscape, the course format shared with QM 47400's print run. Do not change the slide size.</a:t>
             </a:r>
           </a:p>
           <a:p>
             <a:pPr algn="l">
               <a:spcAft>
-                <a:spcPts val="1400"/>
+                <a:spcPts val="900"/>
               </a:spcAft>
             </a:pPr>
             <a:r>
-              <a:rPr sz="3400" b="1" i="0">
+              <a:rPr sz="2200" b="1" i="0">
                 <a:solidFill>
                   <a:srgbClr val="000000"/>
                 </a:solidFill>
                 <a:latin typeface="Arial"/>
               </a:rPr>
-              <a:t>Type at print size:</a:t>
-            </a:r>
-            <a:r>
-              <a:rPr sz="3400" b="0" i="0">
+              <a:t>Type, in this file:</a:t>
+            </a:r>
+            <a:r>
+              <a:rPr sz="2200" b="0" i="0">
                 <a:solidFill>
                   <a:srgbClr val="000000"/>
                 </a:solidFill>
                 <a:latin typeface="Arial"/>
               </a:rPr>
-              <a:t> title 72 pt or more; headline 44 pt; headings 32 pt; everything substantive, including the compass, the data card, the boundary boxes and the AI disclosure, 24 pt; captions, references, acknowledgments and footer 18 pt. If it does not fit, cut or reorganize. Never shrink below these.</a:t>
+              <a:t> title 54 pt; headline 32 pt; headings 24 pt; everything substantive 18 pt; captions, references, acknowledgments and footer 13 pt. If it does not fit, cut or reorganize; never shrink below these.</a:t>
             </a:r>
           </a:p>
           <a:p>
             <a:pPr algn="l">
               <a:spcAft>
-                <a:spcPts val="1400"/>
+                <a:spcPts val="900"/>
               </a:spcAft>
             </a:pPr>
             <a:r>
-              <a:rPr sz="3400" b="1" i="0">
+              <a:rPr sz="2200" b="1" i="0">
                 <a:solidFill>
                   <a:srgbClr val="000000"/>
                 </a:solidFill>
                 <a:latin typeface="Arial"/>
               </a:rPr>
-              <a:t>Figures:</a:t>
-            </a:r>
-            <a:r>
-              <a:rPr sz="3400" b="0" i="0">
+              <a:t>Photo:</a:t>
+            </a:r>
+            <a:r>
+              <a:rPr sz="2200" b="0" i="0">
                 <a:solidFill>
                   <a:srgbClr val="000000"/>
                 </a:solidFill>
                 <a:latin typeface="Arial"/>
               </a:rPr>
-              <a:t> save each one from your notebook as PNG at 300 dpi at the size it will print, or as PDF or SVG. Never paste a screenshot. Right-click → Edit Alt Text, and write what the figure shows.</a:t>
+              <a:t> replace the example photo with yours, or delete it.</a:t>
             </a:r>
           </a:p>
           <a:p>
             <a:pPr algn="l">
               <a:spcAft>
-                <a:spcPts val="1400"/>
+                <a:spcPts val="900"/>
               </a:spcAft>
             </a:pPr>
             <a:r>
-              <a:rPr sz="3400" b="1" i="0">
+              <a:rPr sz="2200" b="1" i="0">
                 <a:solidFill>
                   <a:srgbClr val="000000"/>
                 </a:solidFill>
                 <a:latin typeface="Arial"/>
               </a:rPr>
-              <a:t>Export:</a:t>
-            </a:r>
-            <a:r>
-              <a:rPr sz="3400" b="0" i="0">
+              <a:t>Figures:</a:t>
+            </a:r>
+            <a:r>
+              <a:rPr sz="2200" b="0" i="0">
                 <a:solidFill>
                   <a:srgbClr val="000000"/>
                 </a:solidFill>
                 <a:latin typeface="Arial"/>
               </a:rPr>
-              <a:t> export slide 1 only, as a PDF. Open it and check: exactly one page, 48 × 36 in, nothing clipped, no missing figure. Then print one crop at actual size, without “fit to page”, and measure it with a ruler. Screen zoom does not tell you the printed size.</a:t>
+              <a:t> save each from your notebook as PNG at 300 dpi, or PDF/SVG; never a screenshot. Right-click → Edit Alt Text, and say what it shows.</a:t>
             </a:r>
           </a:p>
           <a:p>
             <a:pPr algn="l">
               <a:spcAft>
-                <a:spcPts val="1400"/>
+                <a:spcPts val="900"/>
               </a:spcAft>
             </a:pPr>
             <a:r>
-              <a:rPr sz="3400" b="1" i="0">
+              <a:rPr sz="2200" b="1" i="0">
                 <a:solidFill>
                   <a:srgbClr val="000000"/>
                 </a:solidFill>
                 <a:latin typeface="Arial"/>
               </a:rPr>
+              <a:t>Export:</a:t>
+            </a:r>
+            <a:r>
+              <a:rPr sz="2200" b="0" i="0">
+                <a:solidFill>
+                  <a:srgbClr val="000000"/>
+                </a:solidFill>
+                <a:latin typeface="Arial"/>
+              </a:rPr>
+              <a:t> slide 1 only, as a PDF: exactly one page, 34 × 22.5 in, nothing clipped.</a:t>
+            </a:r>
+          </a:p>
+          <a:p>
+            <a:pPr algn="l">
+              <a:spcAft>
+                <a:spcPts val="900"/>
+              </a:spcAft>
+            </a:pPr>
+            <a:r>
+              <a:rPr sz="2200" b="1" i="0">
+                <a:solidFill>
+                  <a:srgbClr val="000000"/>
+                </a:solidFill>
+                <a:latin typeface="Arial"/>
+              </a:rPr>
               <a:t>Files:</a:t>
             </a:r>
             <a:r>
-              <a:rPr sz="3400" b="0" i="0">
+              <a:rPr sz="2200" b="0" i="0">
                 <a:solidFill>
                   <a:srgbClr val="000000"/>
                 </a:solidFill>
                 <a:latin typeface="Arial"/>
               </a:rPr>
-              <a:t> M10: lastname_m10_poster.pptx and lastname_m10_poster.pdf. M11: lastname_m11_posterdraft.pdf. M13: lastname_m13_poster.pdf, the print file, poster only.</a:t>
+              <a:t> M10: lastname_m10_poster.pptx + .pdf. M11: lastname_m11_posterdraft.pdf. M13: lastname_m13_poster.pdf, poster only.</a:t>
             </a:r>
           </a:p>
         </p:txBody>
@@ -6049,8 +6616,8 @@
         </p:nvSpPr>
         <p:spPr>
           <a:xfrm>
-            <a:off x="15163800" y="3840480"/>
-            <a:ext cx="13563600" cy="868680"/>
+            <a:off x="10698480" y="2377440"/>
+            <a:ext cx="9692640" cy="548640"/>
           </a:xfrm>
           <a:prstGeom prst="rect">
             <a:avLst/>
@@ -6078,7 +6645,7 @@
           </a:fontRef>
         </p:style>
         <p:txBody>
-          <a:bodyPr rtlCol="0" anchor="ctr" wrap="square" lIns="274320" rIns="274320" tIns="274320" bIns="274320">
+          <a:bodyPr rtlCol="0" anchor="ctr" wrap="square" lIns="182880" rIns="182880" tIns="182880" bIns="182880">
             <a:noAutofit/>
           </a:bodyPr>
           <a:lstStyle/>
@@ -6089,7 +6656,7 @@
               </a:spcAft>
             </a:pPr>
             <a:r>
-              <a:rPr sz="3400" b="1" i="0">
+              <a:rPr sz="2400" b="1" i="0">
                 <a:solidFill>
                   <a:srgbClr val="CFB991"/>
                 </a:solidFill>
@@ -6108,8 +6675,8 @@
         </p:nvSpPr>
         <p:spPr>
           <a:xfrm>
-            <a:off x="15163800" y="4800600"/>
-            <a:ext cx="13563600" cy="26974800"/>
+            <a:off x="10698480" y="3017520"/>
+            <a:ext cx="9692640" cy="15544800"/>
           </a:xfrm>
           <a:prstGeom prst="rect">
             <a:avLst/>
@@ -6124,11 +6691,11 @@
           <a:p>
             <a:pPr algn="l">
               <a:spcAft>
-                <a:spcPts val="1400"/>
+                <a:spcPts val="900"/>
               </a:spcAft>
             </a:pPr>
             <a:r>
-              <a:rPr sz="3400" b="1" i="0">
+              <a:rPr sz="2200" b="1" i="0">
                 <a:solidFill>
                   <a:srgbClr val="000000"/>
                 </a:solidFill>
@@ -6137,48 +6704,48 @@
               <a:t>No result appears first on the poster.</a:t>
             </a:r>
             <a:r>
-              <a:rPr sz="3400" b="0" i="0">
+              <a:rPr sz="2200" b="0" i="0">
                 <a:solidFill>
                   <a:srgbClr val="000000"/>
                 </a:solidFill>
                 <a:latin typeface="Arial"/>
               </a:rPr>
-              <a:t> Every result, figure and citation comes from your M9 note and its claim-evidence table. If a check changes a number, keep the submitted note, write a dated corrected version, then update the poster.</a:t>
+              <a:t> It comes from your M9 note; if a check changes a number, write a dated corrected note first.</a:t>
             </a:r>
           </a:p>
           <a:p>
             <a:pPr algn="l">
               <a:spcAft>
-                <a:spcPts val="1400"/>
+                <a:spcPts val="900"/>
               </a:spcAft>
             </a:pPr>
             <a:r>
-              <a:rPr sz="3400" b="1" i="0">
+              <a:rPr sz="2200" b="1" i="0">
                 <a:solidFill>
                   <a:srgbClr val="000000"/>
                 </a:solidFill>
                 <a:latin typeface="Arial"/>
               </a:rPr>
-              <a:t>Trace what you print.</a:t>
-            </a:r>
-            <a:r>
-              <a:rPr sz="3400" b="0" i="0">
+              <a:t>Trace what you print:</a:t>
+            </a:r>
+            <a:r>
+              <a:rPr sz="2200" b="0" i="0">
                 <a:solidFill>
                   <a:srgbClr val="000000"/>
                 </a:solidFill>
                 <a:latin typeface="Arial"/>
               </a:rPr>
-              <a:t> A result you computed traces to its notebook cell; a statistic from a source traces to that source; rounding is documented.</a:t>
+              <a:t> computed results to their notebook cell, quoted statistics to their source.</a:t>
             </a:r>
           </a:p>
           <a:p>
             <a:pPr algn="l">
               <a:spcAft>
-                <a:spcPts val="1400"/>
+                <a:spcPts val="900"/>
               </a:spcAft>
             </a:pPr>
             <a:r>
-              <a:rPr sz="3400" b="1" i="0">
+              <a:rPr sz="2200" b="1" i="0">
                 <a:solidFill>
                   <a:srgbClr val="000000"/>
                 </a:solidFill>
@@ -6187,23 +6754,23 @@
               <a:t>The qualifier travels with the claim,</a:t>
             </a:r>
             <a:r>
-              <a:rPr sz="3400" b="0" i="0">
+              <a:rPr sz="2200" b="0" i="0">
                 <a:solidFill>
                   <a:srgbClr val="000000"/>
                 </a:solidFill>
                 <a:latin typeface="Arial"/>
               </a:rPr>
-              <a:t> in the same eye-span as the headline.</a:t>
+              <a:t> in the headline's eye-span.</a:t>
             </a:r>
           </a:p>
           <a:p>
             <a:pPr algn="l">
               <a:spcAft>
-                <a:spcPts val="1400"/>
+                <a:spcPts val="900"/>
               </a:spcAft>
             </a:pPr>
             <a:r>
-              <a:rPr sz="3400" b="1" i="0">
+              <a:rPr sz="2200" b="1" i="0">
                 <a:solidFill>
                   <a:srgbClr val="000000"/>
                 </a:solidFill>
@@ -6212,7 +6779,7 @@
               <a:t>Causal wording only with a defended identification argument;</a:t>
             </a:r>
             <a:r>
-              <a:rPr sz="3400" b="0" i="0">
+              <a:rPr sz="2200" b="0" i="0">
                 <a:solidFill>
                   <a:srgbClr val="000000"/>
                 </a:solidFill>
@@ -6224,11 +6791,11 @@
           <a:p>
             <a:pPr algn="l">
               <a:spcAft>
-                <a:spcPts val="1400"/>
+                <a:spcPts val="900"/>
               </a:spcAft>
             </a:pPr>
             <a:r>
-              <a:rPr sz="3400" b="1" i="0">
+              <a:rPr sz="2200" b="1" i="0">
                 <a:solidFill>
                   <a:srgbClr val="000000"/>
                 </a:solidFill>
@@ -6237,48 +6804,48 @@
               <a:t>Two channels for every distinction:</a:t>
             </a:r>
             <a:r>
-              <a:rPr sz="3400" b="0" i="0">
+              <a:rPr sz="2200" b="0" i="0">
                 <a:solidFill>
                   <a:srgbClr val="000000"/>
                 </a:solidFill>
                 <a:latin typeface="Arial"/>
               </a:rPr>
-              <a:t> a label or a pattern, with colour as a bonus.</a:t>
+              <a:t> label or pattern, colour as a bonus.</a:t>
             </a:r>
           </a:p>
           <a:p>
             <a:pPr algn="l">
               <a:spcAft>
-                <a:spcPts val="1400"/>
+                <a:spcPts val="900"/>
               </a:spcAft>
             </a:pPr>
             <a:r>
-              <a:rPr sz="3400" b="1" i="0">
+              <a:rPr sz="2200" b="1" i="0">
                 <a:solidFill>
                   <a:srgbClr val="000000"/>
                 </a:solidFill>
                 <a:latin typeface="Arial"/>
               </a:rPr>
-              <a:t>Replace every bracket, every prompt and every EXAMPLE item.</a:t>
-            </a:r>
-            <a:r>
-              <a:rPr sz="3400" b="0" i="0">
+              <a:t>Replace every bracket, prompt and EXAMPLE item.</a:t>
+            </a:r>
+            <a:r>
+              <a:rPr sz="2200" b="0" i="0">
                 <a:solidFill>
                   <a:srgbClr val="000000"/>
                 </a:solidFill>
                 <a:latin typeface="Arial"/>
               </a:rPr>
-              <a:t> Panels may move, merge or resize; every kind of information stays.</a:t>
+              <a:t> Panels may resize; every section stays.</a:t>
             </a:r>
           </a:p>
           <a:p>
             <a:pPr algn="l">
               <a:spcAft>
-                <a:spcPts val="1400"/>
+                <a:spcPts val="900"/>
               </a:spcAft>
             </a:pPr>
             <a:r>
-              <a:rPr sz="3400" b="1" i="0">
+              <a:rPr sz="2200" b="1" i="0">
                 <a:solidFill>
                   <a:srgbClr val="000000"/>
                 </a:solidFill>
@@ -6287,23 +6854,23 @@
               <a:t>Draft tag through M11; delete it at the M13 lock.</a:t>
             </a:r>
             <a:r>
-              <a:rPr sz="3400" b="0" i="0">
+              <a:rPr sz="2200" b="0" i="0">
                 <a:solidFill>
                   <a:srgbClr val="000000"/>
                 </a:solidFill>
                 <a:latin typeface="Arial"/>
               </a:rPr>
-              <a:t> Keep “Preliminary results” in the footer: the project closes in December.</a:t>
+              <a:t> Keep “Preliminary results” in the footer.</a:t>
             </a:r>
           </a:p>
           <a:p>
             <a:pPr algn="l">
               <a:spcAft>
-                <a:spcPts val="1400"/>
+                <a:spcPts val="900"/>
               </a:spcAft>
             </a:pPr>
             <a:r>
-              <a:rPr sz="3400" b="1" i="0">
+              <a:rPr sz="2200" b="1" i="0">
                 <a:solidFill>
                   <a:srgbClr val="000000"/>
                 </a:solidFill>
@@ -6312,27 +6879,27 @@
               <a:t>AI:</a:t>
             </a:r>
             <a:r>
-              <a:rPr sz="3400" b="0" i="0">
+              <a:rPr sz="2200" b="0" i="0">
                 <a:solidFill>
                   <a:srgbClr val="000000"/>
                 </a:solidFill>
                 <a:latin typeface="Arial"/>
               </a:rPr>
-              <a:t> disclose on the poster itself, per tool: purpose, what you changed or kept, how you checked it. The Expo does not accept AI-generated sections or abstracts, or a poster designed by AI without substantial human input. Every AI step also gets a ledger row.</a:t>
-            </a:r>
-          </a:p>
-        </p:txBody>
-      </p:sp>
-      <p:sp>
-        <p:nvSpPr>
-          <p:cNvPr id="7" name="Heading: PANEL → RUBRIC → BOOK"/>
+              <a:t> disclose on the poster, per tool: purpose, what you changed or kept, how you checked it. The Expo does not accept AI-generated sections or abstracts, or an AI-designed poster.</a:t>
+            </a:r>
+          </a:p>
+        </p:txBody>
+      </p:sp>
+      <p:sp>
+        <p:nvSpPr>
+          <p:cNvPr id="7" name="Heading: SECTION → RUBRIC → BOOK"/>
           <p:cNvSpPr/>
           <p:nvPr/>
         </p:nvSpPr>
         <p:spPr>
           <a:xfrm>
-            <a:off x="29641800" y="3840480"/>
-            <a:ext cx="13563600" cy="868680"/>
+            <a:off x="20939760" y="2377440"/>
+            <a:ext cx="9692640" cy="548640"/>
           </a:xfrm>
           <a:prstGeom prst="rect">
             <a:avLst/>
@@ -6360,7 +6927,7 @@
           </a:fontRef>
         </p:style>
         <p:txBody>
-          <a:bodyPr rtlCol="0" anchor="ctr" wrap="square" lIns="274320" rIns="274320" tIns="274320" bIns="274320">
+          <a:bodyPr rtlCol="0" anchor="ctr" wrap="square" lIns="182880" rIns="182880" tIns="182880" bIns="182880">
             <a:noAutofit/>
           </a:bodyPr>
           <a:lstStyle/>
@@ -6371,28 +6938,28 @@
               </a:spcAft>
             </a:pPr>
             <a:r>
-              <a:rPr sz="3400" b="1" i="0">
+              <a:rPr sz="2400" b="1" i="0">
                 <a:solidFill>
                   <a:srgbClr val="CFB991"/>
                 </a:solidFill>
                 <a:latin typeface="Arial"/>
               </a:rPr>
-              <a:t>PANEL → RUBRIC → BOOK</a:t>
+              <a:t>SECTION → RUBRIC → BOOK</a:t>
             </a:r>
           </a:p>
         </p:txBody>
       </p:sp>
       <p:graphicFrame>
         <p:nvGraphicFramePr>
-          <p:cNvPr id="8" name="Guide: panel map"/>
+          <p:cNvPr id="8" name="Guide: section map"/>
           <p:cNvGraphicFramePr>
             <a:graphicFrameLocks noGrp="1"/>
           </p:cNvGraphicFramePr>
           <p:nvPr/>
         </p:nvGraphicFramePr>
         <p:xfrm>
-          <a:off x="29641800" y="4892040"/>
-          <a:ext cx="13563600" cy="9052560"/>
+          <a:off x="20939760" y="3063240"/>
+          <a:ext cx="9692639" cy="6172200"/>
         </p:xfrm>
         <a:graphic>
           <a:graphicData uri="http://schemas.openxmlformats.org/drawingml/2006/table">
@@ -6401,28 +6968,28 @@
                 <a:tableStyleId>{5C22544A-7EE6-4342-B048-85BDC9FD1C3A}</a:tableStyleId>
               </a:tblPr>
               <a:tblGrid>
-                <a:gridCol w="7711440"/>
-                <a:gridCol w="1828800"/>
-                <a:gridCol w="4023360"/>
+                <a:gridCol w="5669279"/>
+                <a:gridCol w="1188720"/>
+                <a:gridCol w="2834640"/>
               </a:tblGrid>
-              <a:tr h="1005840">
+              <a:tr h="685800">
                 <a:tc>
                   <a:txBody>
                     <a:bodyPr wrap="square"/>
                     <a:lstStyle/>
                     <a:p>
                       <a:r>
-                        <a:rPr sz="2800" b="1">
+                        <a:rPr sz="1800" b="1">
                           <a:solidFill>
                             <a:srgbClr val="CFB991"/>
                           </a:solidFill>
                           <a:latin typeface="Arial"/>
                         </a:rPr>
-                        <a:t>Panel</a:t>
+                        <a:t>Section</a:t>
                       </a:r>
                     </a:p>
                   </a:txBody>
-                  <a:tcPr marL="109728" marR="109728" marT="54864" marB="54864">
+                  <a:tcPr marL="73152" marR="73152" marT="27432" marB="27432">
                     <a:solidFill>
                       <a:srgbClr val="000000"/>
                     </a:solidFill>
@@ -6434,7 +7001,7 @@
                     <a:lstStyle/>
                     <a:p>
                       <a:r>
-                        <a:rPr sz="2800" b="1">
+                        <a:rPr sz="1800" b="1">
                           <a:solidFill>
                             <a:srgbClr val="CFB991"/>
                           </a:solidFill>
@@ -6444,7 +7011,7 @@
                       </a:r>
                     </a:p>
                   </a:txBody>
-                  <a:tcPr marL="109728" marR="109728" marT="54864" marB="54864">
+                  <a:tcPr marL="73152" marR="73152" marT="27432" marB="27432">
                     <a:solidFill>
                       <a:srgbClr val="000000"/>
                     </a:solidFill>
@@ -6456,7 +7023,7 @@
                     <a:lstStyle/>
                     <a:p>
                       <a:r>
-                        <a:rPr sz="2800" b="1">
+                        <a:rPr sz="1800" b="1">
                           <a:solidFill>
                             <a:srgbClr val="CFB991"/>
                           </a:solidFill>
@@ -6466,31 +7033,31 @@
                       </a:r>
                     </a:p>
                   </a:txBody>
-                  <a:tcPr marL="109728" marR="109728" marT="54864" marB="54864">
+                  <a:tcPr marL="73152" marR="73152" marT="27432" marB="27432">
                     <a:solidFill>
                       <a:srgbClr val="000000"/>
                     </a:solidFill>
                   </a:tcPr>
                 </a:tc>
               </a:tr>
-              <a:tr h="1005840">
+              <a:tr h="685800">
                 <a:tc>
                   <a:txBody>
                     <a:bodyPr wrap="square"/>
                     <a:lstStyle/>
                     <a:p>
                       <a:r>
-                        <a:rPr sz="2800" b="0">
+                        <a:rPr sz="1800" b="0">
                           <a:solidFill>
                             <a:srgbClr val="000000"/>
                           </a:solidFill>
                           <a:latin typeface="Arial"/>
                         </a:rPr>
-                        <a:t>Title · The question and what it adds</a:t>
+                        <a:t>Title · Abstract · The question · What is already known</a:t>
                       </a:r>
                     </a:p>
                   </a:txBody>
-                  <a:tcPr marL="109728" marR="109728" marT="54864" marB="54864">
+                  <a:tcPr marL="73152" marR="73152" marT="27432" marB="27432">
                     <a:solidFill>
                       <a:srgbClr val="FFFFFF"/>
                     </a:solidFill>
@@ -6502,7 +7069,7 @@
                     <a:lstStyle/>
                     <a:p>
                       <a:r>
-                        <a:rPr sz="2800" b="0">
+                        <a:rPr sz="1800" b="0">
                           <a:solidFill>
                             <a:srgbClr val="000000"/>
                           </a:solidFill>
@@ -6512,7 +7079,7 @@
                       </a:r>
                     </a:p>
                   </a:txBody>
-                  <a:tcPr marL="109728" marR="109728" marT="54864" marB="54864">
+                  <a:tcPr marL="73152" marR="73152" marT="27432" marB="27432">
                     <a:solidFill>
                       <a:srgbClr val="FFFFFF"/>
                     </a:solidFill>
@@ -6524,7 +7091,7 @@
                     <a:lstStyle/>
                     <a:p>
                       <a:r>
-                        <a:rPr sz="2800" b="0">
+                        <a:rPr sz="1800" b="0">
                           <a:solidFill>
                             <a:srgbClr val="000000"/>
                           </a:solidFill>
@@ -6534,21 +7101,21 @@
                       </a:r>
                     </a:p>
                   </a:txBody>
-                  <a:tcPr marL="109728" marR="109728" marT="54864" marB="54864">
+                  <a:tcPr marL="73152" marR="73152" marT="27432" marB="27432">
                     <a:solidFill>
                       <a:srgbClr val="FFFFFF"/>
                     </a:solidFill>
                   </a:tcPr>
                 </a:tc>
               </a:tr>
-              <a:tr h="1005840">
+              <a:tr h="685800">
                 <a:tc>
                   <a:txBody>
                     <a:bodyPr wrap="square"/>
                     <a:lstStyle/>
                     <a:p>
                       <a:r>
-                        <a:rPr sz="2800" b="0">
+                        <a:rPr sz="1800" b="0">
                           <a:solidFill>
                             <a:srgbClr val="000000"/>
                           </a:solidFill>
@@ -6558,7 +7125,7 @@
                       </a:r>
                     </a:p>
                   </a:txBody>
-                  <a:tcPr marL="109728" marR="109728" marT="54864" marB="54864">
+                  <a:tcPr marL="73152" marR="73152" marT="27432" marB="27432">
                     <a:solidFill>
                       <a:srgbClr val="FFFFFF"/>
                     </a:solidFill>
@@ -6570,7 +7137,7 @@
                     <a:lstStyle/>
                     <a:p>
                       <a:r>
-                        <a:rPr sz="2800" b="0">
+                        <a:rPr sz="1800" b="0">
                           <a:solidFill>
                             <a:srgbClr val="000000"/>
                           </a:solidFill>
@@ -6580,7 +7147,7 @@
                       </a:r>
                     </a:p>
                   </a:txBody>
-                  <a:tcPr marL="109728" marR="109728" marT="54864" marB="54864">
+                  <a:tcPr marL="73152" marR="73152" marT="27432" marB="27432">
                     <a:solidFill>
                       <a:srgbClr val="FFFFFF"/>
                     </a:solidFill>
@@ -6592,7 +7159,7 @@
                     <a:lstStyle/>
                     <a:p>
                       <a:r>
-                        <a:rPr sz="2800" b="0">
+                        <a:rPr sz="1800" b="0">
                           <a:solidFill>
                             <a:srgbClr val="000000"/>
                           </a:solidFill>
@@ -6602,21 +7169,21 @@
                       </a:r>
                     </a:p>
                   </a:txBody>
-                  <a:tcPr marL="109728" marR="109728" marT="54864" marB="54864">
+                  <a:tcPr marL="73152" marR="73152" marT="27432" marB="27432">
                     <a:solidFill>
                       <a:srgbClr val="FFFFFF"/>
                     </a:solidFill>
                   </a:tcPr>
                 </a:tc>
               </a:tr>
-              <a:tr h="1005840">
+              <a:tr h="685800">
                 <a:tc>
                   <a:txBody>
                     <a:bodyPr wrap="square"/>
                     <a:lstStyle/>
                     <a:p>
                       <a:r>
-                        <a:rPr sz="2800" b="0">
+                        <a:rPr sz="1800" b="0">
                           <a:solidFill>
                             <a:srgbClr val="000000"/>
                           </a:solidFill>
@@ -6626,7 +7193,7 @@
                       </a:r>
                     </a:p>
                   </a:txBody>
-                  <a:tcPr marL="109728" marR="109728" marT="54864" marB="54864">
+                  <a:tcPr marL="73152" marR="73152" marT="27432" marB="27432">
                     <a:solidFill>
                       <a:srgbClr val="FFFFFF"/>
                     </a:solidFill>
@@ -6638,7 +7205,7 @@
                     <a:lstStyle/>
                     <a:p>
                       <a:r>
-                        <a:rPr sz="2800" b="0">
+                        <a:rPr sz="1800" b="0">
                           <a:solidFill>
                             <a:srgbClr val="000000"/>
                           </a:solidFill>
@@ -6648,7 +7215,7 @@
                       </a:r>
                     </a:p>
                   </a:txBody>
-                  <a:tcPr marL="109728" marR="109728" marT="54864" marB="54864">
+                  <a:tcPr marL="73152" marR="73152" marT="27432" marB="27432">
                     <a:solidFill>
                       <a:srgbClr val="FFFFFF"/>
                     </a:solidFill>
@@ -6660,7 +7227,7 @@
                     <a:lstStyle/>
                     <a:p>
                       <a:r>
-                        <a:rPr sz="2800" b="0">
+                        <a:rPr sz="1800" b="0">
                           <a:solidFill>
                             <a:srgbClr val="000000"/>
                           </a:solidFill>
@@ -6670,31 +7237,31 @@
                       </a:r>
                     </a:p>
                   </a:txBody>
-                  <a:tcPr marL="109728" marR="109728" marT="54864" marB="54864">
+                  <a:tcPr marL="73152" marR="73152" marT="27432" marB="27432">
                     <a:solidFill>
                       <a:srgbClr val="FFFFFF"/>
                     </a:solidFill>
                   </a:tcPr>
                 </a:tc>
               </a:tr>
-              <a:tr h="1005840">
+              <a:tr h="685800">
                 <a:tc>
                   <a:txBody>
                     <a:bodyPr wrap="square"/>
                     <a:lstStyle/>
                     <a:p>
                       <a:r>
-                        <a:rPr sz="2800" b="0">
+                        <a:rPr sz="1800" b="0">
                           <a:solidFill>
                             <a:srgbClr val="000000"/>
                           </a:solidFill>
                           <a:latin typeface="Arial"/>
                         </a:rPr>
-                        <a:t>Checks and verification · status line</a:t>
+                        <a:t>Methods · Checks and verification</a:t>
                       </a:r>
                     </a:p>
                   </a:txBody>
-                  <a:tcPr marL="109728" marR="109728" marT="54864" marB="54864">
+                  <a:tcPr marL="73152" marR="73152" marT="27432" marB="27432">
                     <a:solidFill>
                       <a:srgbClr val="FFFFFF"/>
                     </a:solidFill>
@@ -6706,7 +7273,7 @@
                     <a:lstStyle/>
                     <a:p>
                       <a:r>
-                        <a:rPr sz="2800" b="0">
+                        <a:rPr sz="1800" b="0">
                           <a:solidFill>
                             <a:srgbClr val="000000"/>
                           </a:solidFill>
@@ -6716,7 +7283,7 @@
                       </a:r>
                     </a:p>
                   </a:txBody>
-                  <a:tcPr marL="109728" marR="109728" marT="54864" marB="54864">
+                  <a:tcPr marL="73152" marR="73152" marT="27432" marB="27432">
                     <a:solidFill>
                       <a:srgbClr val="FFFFFF"/>
                     </a:solidFill>
@@ -6728,7 +7295,7 @@
                     <a:lstStyle/>
                     <a:p>
                       <a:r>
-                        <a:rPr sz="2800" b="0">
+                        <a:rPr sz="1800" b="0">
                           <a:solidFill>
                             <a:srgbClr val="000000"/>
                           </a:solidFill>
@@ -6738,21 +7305,21 @@
                       </a:r>
                     </a:p>
                   </a:txBody>
-                  <a:tcPr marL="109728" marR="109728" marT="54864" marB="54864">
+                  <a:tcPr marL="73152" marR="73152" marT="27432" marB="27432">
                     <a:solidFill>
                       <a:srgbClr val="FFFFFF"/>
                     </a:solidFill>
                   </a:tcPr>
                 </a:tc>
               </a:tr>
-              <a:tr h="1005840">
+              <a:tr h="685800">
                 <a:tc>
                   <a:txBody>
                     <a:bodyPr wrap="square"/>
                     <a:lstStyle/>
                     <a:p>
                       <a:r>
-                        <a:rPr sz="2800" b="0">
+                        <a:rPr sz="1800" b="0">
                           <a:solidFill>
                             <a:srgbClr val="000000"/>
                           </a:solidFill>
@@ -6762,7 +7329,7 @@
                       </a:r>
                     </a:p>
                   </a:txBody>
-                  <a:tcPr marL="109728" marR="109728" marT="54864" marB="54864">
+                  <a:tcPr marL="73152" marR="73152" marT="27432" marB="27432">
                     <a:solidFill>
                       <a:srgbClr val="FFFFFF"/>
                     </a:solidFill>
@@ -6774,7 +7341,7 @@
                     <a:lstStyle/>
                     <a:p>
                       <a:r>
-                        <a:rPr sz="2800" b="0">
+                        <a:rPr sz="1800" b="0">
                           <a:solidFill>
                             <a:srgbClr val="000000"/>
                           </a:solidFill>
@@ -6784,7 +7351,7 @@
                       </a:r>
                     </a:p>
                   </a:txBody>
-                  <a:tcPr marL="109728" marR="109728" marT="54864" marB="54864">
+                  <a:tcPr marL="73152" marR="73152" marT="27432" marB="27432">
                     <a:solidFill>
                       <a:srgbClr val="FFFFFF"/>
                     </a:solidFill>
@@ -6796,7 +7363,7 @@
                     <a:lstStyle/>
                     <a:p>
                       <a:r>
-                        <a:rPr sz="2800" b="0">
+                        <a:rPr sz="1800" b="0">
                           <a:solidFill>
                             <a:srgbClr val="000000"/>
                           </a:solidFill>
@@ -6806,31 +7373,31 @@
                       </a:r>
                     </a:p>
                   </a:txBody>
-                  <a:tcPr marL="109728" marR="109728" marT="54864" marB="54864">
+                  <a:tcPr marL="73152" marR="73152" marT="27432" marB="27432">
                     <a:solidFill>
                       <a:srgbClr val="FFFFFF"/>
                     </a:solidFill>
                   </a:tcPr>
                 </a:tc>
               </a:tr>
-              <a:tr h="1005840">
+              <a:tr h="685800">
                 <a:tc>
                   <a:txBody>
                     <a:bodyPr wrap="square"/>
                     <a:lstStyle/>
                     <a:p>
                       <a:r>
-                        <a:rPr sz="2800" b="0">
+                        <a:rPr sz="1800" b="0">
                           <a:solidFill>
                             <a:srgbClr val="000000"/>
                           </a:solidFill>
                           <a:latin typeface="Arial"/>
                         </a:rPr>
-                        <a:t>Headline · What it means, and where it stops</a:t>
+                        <a:t>Headline · Conclusions · Limitations</a:t>
                       </a:r>
                     </a:p>
                   </a:txBody>
-                  <a:tcPr marL="109728" marR="109728" marT="54864" marB="54864">
+                  <a:tcPr marL="73152" marR="73152" marT="27432" marB="27432">
                     <a:solidFill>
                       <a:srgbClr val="FFFFFF"/>
                     </a:solidFill>
@@ -6842,7 +7409,7 @@
                     <a:lstStyle/>
                     <a:p>
                       <a:r>
-                        <a:rPr sz="2800" b="0">
+                        <a:rPr sz="1800" b="0">
                           <a:solidFill>
                             <a:srgbClr val="000000"/>
                           </a:solidFill>
@@ -6852,7 +7419,7 @@
                       </a:r>
                     </a:p>
                   </a:txBody>
-                  <a:tcPr marL="109728" marR="109728" marT="54864" marB="54864">
+                  <a:tcPr marL="73152" marR="73152" marT="27432" marB="27432">
                     <a:solidFill>
                       <a:srgbClr val="FFFFFF"/>
                     </a:solidFill>
@@ -6864,7 +7431,7 @@
                     <a:lstStyle/>
                     <a:p>
                       <a:r>
-                        <a:rPr sz="2800" b="0">
+                        <a:rPr sz="1800" b="0">
                           <a:solidFill>
                             <a:srgbClr val="000000"/>
                           </a:solidFill>
@@ -6874,31 +7441,31 @@
                       </a:r>
                     </a:p>
                   </a:txBody>
-                  <a:tcPr marL="109728" marR="109728" marT="54864" marB="54864">
+                  <a:tcPr marL="73152" marR="73152" marT="27432" marB="27432">
                     <a:solidFill>
                       <a:srgbClr val="FFFFFF"/>
                     </a:solidFill>
                   </a:tcPr>
                 </a:tc>
               </a:tr>
-              <a:tr h="1005840">
+              <a:tr h="685800">
                 <a:tc>
                   <a:txBody>
                     <a:bodyPr wrap="square"/>
                     <a:lstStyle/>
                     <a:p>
                       <a:r>
-                        <a:rPr sz="2800" b="0">
+                        <a:rPr sz="1800" b="0">
                           <a:solidFill>
                             <a:srgbClr val="000000"/>
                           </a:solidFill>
                           <a:latin typeface="Arial"/>
                         </a:rPr>
-                        <a:t>Sources, AI use, and credits</a:t>
+                        <a:t>AI use disclosure · References · Acknowledgments</a:t>
                       </a:r>
                     </a:p>
                   </a:txBody>
-                  <a:tcPr marL="109728" marR="109728" marT="54864" marB="54864">
+                  <a:tcPr marL="73152" marR="73152" marT="27432" marB="27432">
                     <a:solidFill>
                       <a:srgbClr val="FFFFFF"/>
                     </a:solidFill>
@@ -6910,7 +7477,7 @@
                     <a:lstStyle/>
                     <a:p>
                       <a:r>
-                        <a:rPr sz="2800" b="0">
+                        <a:rPr sz="1800" b="0">
                           <a:solidFill>
                             <a:srgbClr val="000000"/>
                           </a:solidFill>
@@ -6920,7 +7487,7 @@
                       </a:r>
                     </a:p>
                   </a:txBody>
-                  <a:tcPr marL="109728" marR="109728" marT="54864" marB="54864">
+                  <a:tcPr marL="73152" marR="73152" marT="27432" marB="27432">
                     <a:solidFill>
                       <a:srgbClr val="FFFFFF"/>
                     </a:solidFill>
@@ -6932,7 +7499,7 @@
                     <a:lstStyle/>
                     <a:p>
                       <a:r>
-                        <a:rPr sz="2800" b="0">
+                        <a:rPr sz="1800" b="0">
                           <a:solidFill>
                             <a:srgbClr val="000000"/>
                           </a:solidFill>
@@ -6942,21 +7509,21 @@
                       </a:r>
                     </a:p>
                   </a:txBody>
-                  <a:tcPr marL="109728" marR="109728" marT="54864" marB="54864">
+                  <a:tcPr marL="73152" marR="73152" marT="27432" marB="27432">
                     <a:solidFill>
                       <a:srgbClr val="FFFFFF"/>
                     </a:solidFill>
                   </a:tcPr>
                 </a:tc>
               </a:tr>
-              <a:tr h="1005840">
+              <a:tr h="685800">
                 <a:tc>
                   <a:txBody>
                     <a:bodyPr wrap="square"/>
                     <a:lstStyle/>
                     <a:p>
                       <a:r>
-                        <a:rPr sz="2800" b="0">
+                        <a:rPr sz="1800" b="0">
                           <a:solidFill>
                             <a:srgbClr val="000000"/>
                           </a:solidFill>
@@ -6966,7 +7533,7 @@
                       </a:r>
                     </a:p>
                   </a:txBody>
-                  <a:tcPr marL="109728" marR="109728" marT="54864" marB="54864">
+                  <a:tcPr marL="73152" marR="73152" marT="27432" marB="27432">
                     <a:solidFill>
                       <a:srgbClr val="FFFFFF"/>
                     </a:solidFill>
@@ -6978,7 +7545,7 @@
                     <a:lstStyle/>
                     <a:p>
                       <a:r>
-                        <a:rPr sz="2800" b="0">
+                        <a:rPr sz="1800" b="0">
                           <a:solidFill>
                             <a:srgbClr val="000000"/>
                           </a:solidFill>
@@ -6988,7 +7555,7 @@
                       </a:r>
                     </a:p>
                   </a:txBody>
-                  <a:tcPr marL="109728" marR="109728" marT="54864" marB="54864">
+                  <a:tcPr marL="73152" marR="73152" marT="27432" marB="27432">
                     <a:solidFill>
                       <a:srgbClr val="FFFFFF"/>
                     </a:solidFill>
@@ -7000,7 +7567,7 @@
                     <a:lstStyle/>
                     <a:p>
                       <a:r>
-                        <a:rPr sz="2800" b="0">
+                        <a:rPr sz="1800" b="0">
                           <a:solidFill>
                             <a:srgbClr val="000000"/>
                           </a:solidFill>
@@ -7010,7 +7577,7 @@
                       </a:r>
                     </a:p>
                   </a:txBody>
-                  <a:tcPr marL="109728" marR="109728" marT="54864" marB="54864">
+                  <a:tcPr marL="73152" marR="73152" marT="27432" marB="27432">
                     <a:solidFill>
                       <a:srgbClr val="FFFFFF"/>
                     </a:solidFill>
@@ -7029,8 +7596,8 @@
         </p:nvSpPr>
         <p:spPr>
           <a:xfrm>
-            <a:off x="29641800" y="16002000"/>
-            <a:ext cx="13563600" cy="7315200"/>
+            <a:off x="20939760" y="10515600"/>
+            <a:ext cx="9692640" cy="3657600"/>
           </a:xfrm>
           <a:prstGeom prst="rect">
             <a:avLst/>
@@ -7045,17 +7612,17 @@
           <a:p>
             <a:pPr algn="l">
               <a:spcAft>
-                <a:spcPts val="1400"/>
+                <a:spcPts val="900"/>
               </a:spcAft>
             </a:pPr>
             <a:r>
-              <a:rPr sz="3400" b="0" i="0">
+              <a:rPr sz="2200" b="0" i="0">
                 <a:solidFill>
                   <a:srgbClr val="000000"/>
                 </a:solidFill>
                 <a:latin typeface="Arial"/>
               </a:rPr>
-              <a:t>The final poster (M13) is graded with Evidence_Driven_Research_Poster_Rubric.pdf, handed out with this template: eight criteria, 100 points, with hard caps. Read it before you build, not after.</a:t>
+              <a:t>The final poster (M13) is graded with Evidence_Driven_Research_Poster_Rubric.pdf: eight criteria, 100 points, hard caps. Read it before you build.</a:t>
             </a:r>
           </a:p>
         </p:txBody>

</xml_diff>

<commit_message>
chore: Session auto commit (Claude Code Stop hook)
Automated commit + push at the end of a Claude Code session/turn.
Tracked changes only; docs/ re-rendered when content changed.

Co-Authored-By: Claude Sonnet 4.5 <noreply@anthropic.com>
</commit_message>
<xml_diff>
--- a/project/poster/honr464_poster_template.pptx
+++ b/project/poster/honr464_poster_template.pptx
@@ -6701,7 +6701,7 @@
                 </a:solidFill>
                 <a:latin typeface="Arial"/>
               </a:rPr>
-              <a:t>No result appears first on the poster.</a:t>
+              <a:t>Start from your M9 note:</a:t>
             </a:r>
             <a:r>
               <a:rPr sz="2200" b="0" i="0">
@@ -6710,7 +6710,7 @@
                 </a:solidFill>
                 <a:latin typeface="Arial"/>
               </a:rPr>
-              <a:t> It comes from your M9 note; if a check changes a number, write a dated corrected note first.</a:t>
+              <a:t> each of its sections drafts the panel with the same name.</a:t>
             </a:r>
           </a:p>
           <a:p>
@@ -6726,7 +6726,7 @@
                 </a:solidFill>
                 <a:latin typeface="Arial"/>
               </a:rPr>
-              <a:t>Trace what you print:</a:t>
+              <a:t>New is welcome; untraced is not.</a:t>
             </a:r>
             <a:r>
               <a:rPr sz="2200" b="0" i="0">
@@ -6735,7 +6735,7 @@
                 </a:solidFill>
                 <a:latin typeface="Arial"/>
               </a:rPr>
-              <a:t> computed results to their notebook cell, quoted statistics to their source.</a:t>
+              <a:t> Anything added after M9 gets a row in your claim-to-evidence table first: computed results to their notebook cell, quoted statistics to their source.</a:t>
             </a:r>
           </a:p>
           <a:p>

</xml_diff>

<commit_message>
fix: D87 amended — M10 requires the template guide page and a rubric self-check; M11 collects the complete poster PDF
M10 brief, PDF and workbench: start from the template file, follow its hidden
guide page, hand in a one-line-per-criterion rubric self-check. M11: the
complete poster PDF (lastname_m11_poster.pdf) on the template, every section
final, M13 still the print lock; M11's PDF gains a course-additions section.
The template guide's rubric map is now generated from RUBRIC (it was stale).

Co-Authored-By: Claude Opus 5.5 <noreply@anthropic.com>
</commit_message>
<xml_diff>
--- a/project/poster/honr464_poster_template.pptx
+++ b/project/poster/honr464_poster_template.pptx
@@ -6603,7 +6603,7 @@
                 </a:solidFill>
                 <a:latin typeface="Arial"/>
               </a:rPr>
-              <a:t> M10: lastname_m10_poster.pptx + .pdf. M11: lastname_m11_posterdraft.pdf. M13: lastname_m13_poster.pdf, poster only.</a:t>
+              <a:t> M10: lastname_m10_poster.pptx + .pdf. M11: lastname_m11_poster.pdf, the complete poster. M13: lastname_m13_poster.pdf, the locked print file, poster only.</a:t>
             </a:r>
           </a:p>
         </p:txBody>
@@ -6851,7 +6851,7 @@
                 </a:solidFill>
                 <a:latin typeface="Arial"/>
               </a:rPr>
-              <a:t>Draft tag through M11; delete it at the M13 lock.</a:t>
+              <a:t>Check the board against the rubric</a:t>
             </a:r>
             <a:r>
               <a:rPr sz="2200" b="0" i="0">
@@ -6860,7 +6860,7 @@
                 </a:solidFill>
                 <a:latin typeface="Arial"/>
               </a:rPr>
-              <a:t> Keep “Preliminary results” in the footer.</a:t>
+              <a:t> before M10 and M11: one line per criterion in your rubric self-check.</a:t>
             </a:r>
           </a:p>
           <a:p>
@@ -6876,6 +6876,31 @@
                 </a:solidFill>
                 <a:latin typeface="Arial"/>
               </a:rPr>
+              <a:t>Draft tag through M11; delete it at the M13 lock.</a:t>
+            </a:r>
+            <a:r>
+              <a:rPr sz="2200" b="0" i="0">
+                <a:solidFill>
+                  <a:srgbClr val="000000"/>
+                </a:solidFill>
+                <a:latin typeface="Arial"/>
+              </a:rPr>
+              <a:t> Keep “Preliminary results” in the footer.</a:t>
+            </a:r>
+          </a:p>
+          <a:p>
+            <a:pPr algn="l">
+              <a:spcAft>
+                <a:spcPts val="900"/>
+              </a:spcAft>
+            </a:pPr>
+            <a:r>
+              <a:rPr sz="2200" b="1" i="0">
+                <a:solidFill>
+                  <a:srgbClr val="000000"/>
+                </a:solidFill>
+                <a:latin typeface="Arial"/>
+              </a:rPr>
               <a:t>AI:</a:t>
             </a:r>
             <a:r>
@@ -6892,7 +6917,7 @@
       </p:sp>
       <p:sp>
         <p:nvSpPr>
-          <p:cNvPr id="7" name="Heading: SECTION → RUBRIC → BOOK"/>
+          <p:cNvPr id="7" name="Heading: RUBRIC → SECTIONS → BOOK"/>
           <p:cNvSpPr/>
           <p:nvPr/>
         </p:nvSpPr>
@@ -6944,14 +6969,14 @@
                 </a:solidFill>
                 <a:latin typeface="Arial"/>
               </a:rPr>
-              <a:t>SECTION → RUBRIC → BOOK</a:t>
+              <a:t>RUBRIC → SECTIONS → BOOK</a:t>
             </a:r>
           </a:p>
         </p:txBody>
       </p:sp>
       <p:graphicFrame>
         <p:nvGraphicFramePr>
-          <p:cNvPr id="8" name="Guide: section map"/>
+          <p:cNvPr id="8" name="Guide: rubric map"/>
           <p:cNvGraphicFramePr>
             <a:graphicFrameLocks noGrp="1"/>
           </p:cNvGraphicFramePr>
@@ -6959,7 +6984,7 @@
         </p:nvGraphicFramePr>
         <p:xfrm>
           <a:off x="20939760" y="3063240"/>
-          <a:ext cx="9692639" cy="6172200"/>
+          <a:ext cx="9692639" cy="7818119"/>
         </p:xfrm>
         <a:graphic>
           <a:graphicData uri="http://schemas.openxmlformats.org/drawingml/2006/table">
@@ -6968,24 +6993,24 @@
                 <a:tableStyleId>{5C22544A-7EE6-4342-B048-85BDC9FD1C3A}</a:tableStyleId>
               </a:tblPr>
               <a:tblGrid>
-                <a:gridCol w="5669279"/>
-                <a:gridCol w="1188720"/>
-                <a:gridCol w="2834640"/>
+                <a:gridCol w="3566160"/>
+                <a:gridCol w="4023359"/>
+                <a:gridCol w="2103120"/>
               </a:tblGrid>
-              <a:tr h="685800">
+              <a:tr h="868679">
                 <a:tc>
                   <a:txBody>
                     <a:bodyPr wrap="square"/>
                     <a:lstStyle/>
                     <a:p>
                       <a:r>
-                        <a:rPr sz="1800" b="1">
+                        <a:rPr sz="1400" b="1">
                           <a:solidFill>
                             <a:srgbClr val="CFB991"/>
                           </a:solidFill>
                           <a:latin typeface="Arial"/>
                         </a:rPr>
-                        <a:t>Section</a:t>
+                        <a:t>Rubric criterion</a:t>
                       </a:r>
                     </a:p>
                   </a:txBody>
@@ -7001,13 +7026,13 @@
                     <a:lstStyle/>
                     <a:p>
                       <a:r>
-                        <a:rPr sz="1800" b="1">
+                        <a:rPr sz="1400" b="1">
                           <a:solidFill>
                             <a:srgbClr val="CFB991"/>
                           </a:solidFill>
                           <a:latin typeface="Arial"/>
                         </a:rPr>
-                        <a:t>Rubric</a:t>
+                        <a:t>Sections it reads</a:t>
                       </a:r>
                     </a:p>
                   </a:txBody>
@@ -7023,7 +7048,7 @@
                     <a:lstStyle/>
                     <a:p>
                       <a:r>
-                        <a:rPr sz="1800" b="1">
+                        <a:rPr sz="1400" b="1">
                           <a:solidFill>
                             <a:srgbClr val="CFB991"/>
                           </a:solidFill>
@@ -7040,20 +7065,20 @@
                   </a:tcPr>
                 </a:tc>
               </a:tr>
-              <a:tr h="685800">
+              <a:tr h="868679">
                 <a:tc>
                   <a:txBody>
                     <a:bodyPr wrap="square"/>
                     <a:lstStyle/>
                     <a:p>
                       <a:r>
-                        <a:rPr sz="1800" b="0">
+                        <a:rPr sz="1400" b="0">
                           <a:solidFill>
                             <a:srgbClr val="000000"/>
                           </a:solidFill>
                           <a:latin typeface="Arial"/>
                         </a:rPr>
-                        <a:t>Title · Abstract · The question · What is already known</a:t>
+                        <a:t>1. Question, context &amp; contribution (10)</a:t>
                       </a:r>
                     </a:p>
                   </a:txBody>
@@ -7069,13 +7094,13 @@
                     <a:lstStyle/>
                     <a:p>
                       <a:r>
-                        <a:rPr sz="1800" b="0">
+                        <a:rPr sz="1400" b="0">
                           <a:solidFill>
                             <a:srgbClr val="000000"/>
                           </a:solidFill>
                           <a:latin typeface="Arial"/>
                         </a:rPr>
-                        <a:t>1</a:t>
+                        <a:t>Title · Abstract · The question and why it matters · What is already known</a:t>
                       </a:r>
                     </a:p>
                   </a:txBody>
@@ -7091,7 +7116,7 @@
                     <a:lstStyle/>
                     <a:p>
                       <a:r>
-                        <a:rPr sz="1800" b="0">
+                        <a:rPr sz="1400" b="0">
                           <a:solidFill>
                             <a:srgbClr val="000000"/>
                           </a:solidFill>
@@ -7108,14 +7133,36 @@
                   </a:tcPr>
                 </a:tc>
               </a:tr>
-              <a:tr h="685800">
+              <a:tr h="868679">
                 <a:tc>
                   <a:txBody>
                     <a:bodyPr wrap="square"/>
                     <a:lstStyle/>
                     <a:p>
                       <a:r>
-                        <a:rPr sz="1800" b="0">
+                        <a:rPr sz="1400" b="0">
+                          <a:solidFill>
+                            <a:srgbClr val="000000"/>
+                          </a:solidFill>
+                          <a:latin typeface="Arial"/>
+                        </a:rPr>
+                        <a:t>2. Target, design &amp; warranted claims (15)</a:t>
+                      </a:r>
+                    </a:p>
+                  </a:txBody>
+                  <a:tcPr marL="73152" marR="73152" marT="27432" marB="27432">
+                    <a:solidFill>
+                      <a:srgbClr val="FFFFFF"/>
+                    </a:solidFill>
+                  </a:tcPr>
+                </a:tc>
+                <a:tc>
+                  <a:txBody>
+                    <a:bodyPr wrap="square"/>
+                    <a:lstStyle/>
+                    <a:p>
+                      <a:r>
+                        <a:rPr sz="1400" b="0">
                           <a:solidFill>
                             <a:srgbClr val="000000"/>
                           </a:solidFill>
@@ -7137,29 +7184,7 @@
                     <a:lstStyle/>
                     <a:p>
                       <a:r>
-                        <a:rPr sz="1800" b="0">
-                          <a:solidFill>
-                            <a:srgbClr val="000000"/>
-                          </a:solidFill>
-                          <a:latin typeface="Arial"/>
-                        </a:rPr>
-                        <a:t>2</a:t>
-                      </a:r>
-                    </a:p>
-                  </a:txBody>
-                  <a:tcPr marL="73152" marR="73152" marT="27432" marB="27432">
-                    <a:solidFill>
-                      <a:srgbClr val="FFFFFF"/>
-                    </a:solidFill>
-                  </a:tcPr>
-                </a:tc>
-                <a:tc>
-                  <a:txBody>
-                    <a:bodyPr wrap="square"/>
-                    <a:lstStyle/>
-                    <a:p>
-                      <a:r>
-                        <a:rPr sz="1800" b="0">
+                        <a:rPr sz="1400" b="0">
                           <a:solidFill>
                             <a:srgbClr val="000000"/>
                           </a:solidFill>
@@ -7176,20 +7201,20 @@
                   </a:tcPr>
                 </a:tc>
               </a:tr>
-              <a:tr h="685800">
+              <a:tr h="868679">
                 <a:tc>
                   <a:txBody>
                     <a:bodyPr wrap="square"/>
                     <a:lstStyle/>
                     <a:p>
                       <a:r>
-                        <a:rPr sz="1800" b="0">
+                        <a:rPr sz="1400" b="0">
                           <a:solidFill>
                             <a:srgbClr val="000000"/>
                           </a:solidFill>
                           <a:latin typeface="Arial"/>
                         </a:rPr>
-                        <a:t>Data and measurement</a:t>
+                        <a:t>3. Research design &amp; methodology (15)</a:t>
                       </a:r>
                     </a:p>
                   </a:txBody>
@@ -7205,13 +7230,13 @@
                     <a:lstStyle/>
                     <a:p>
                       <a:r>
-                        <a:rPr sz="1800" b="0">
+                        <a:rPr sz="1400" b="0">
                           <a:solidFill>
                             <a:srgbClr val="000000"/>
                           </a:solidFill>
                           <a:latin typeface="Arial"/>
                         </a:rPr>
-                        <a:t>3</a:t>
+                        <a:t>Design: what your claim needs · Data and measurement · Methods</a:t>
                       </a:r>
                     </a:p>
                   </a:txBody>
@@ -7227,13 +7252,13 @@
                     <a:lstStyle/>
                     <a:p>
                       <a:r>
-                        <a:rPr sz="1800" b="0">
+                        <a:rPr sz="1400" b="0">
                           <a:solidFill>
                             <a:srgbClr val="000000"/>
                           </a:solidFill>
                           <a:latin typeface="Arial"/>
                         </a:rPr>
-                        <a:t>Ch. 13, 20–21</a:t>
+                        <a:t>Ch. 10, 12–21</a:t>
                       </a:r>
                     </a:p>
                   </a:txBody>
@@ -7244,20 +7269,20 @@
                   </a:tcPr>
                 </a:tc>
               </a:tr>
-              <a:tr h="685800">
+              <a:tr h="868679">
                 <a:tc>
                   <a:txBody>
                     <a:bodyPr wrap="square"/>
                     <a:lstStyle/>
                     <a:p>
                       <a:r>
-                        <a:rPr sz="1800" b="0">
+                        <a:rPr sz="1400" b="0">
                           <a:solidFill>
                             <a:srgbClr val="000000"/>
                           </a:solidFill>
                           <a:latin typeface="Arial"/>
                         </a:rPr>
-                        <a:t>Methods · Checks and verification</a:t>
+                        <a:t>4. Checks &amp; verification (12)</a:t>
                       </a:r>
                     </a:p>
                   </a:txBody>
@@ -7273,13 +7298,13 @@
                     <a:lstStyle/>
                     <a:p>
                       <a:r>
-                        <a:rPr sz="1800" b="0">
+                        <a:rPr sz="1400" b="0">
                           <a:solidFill>
                             <a:srgbClr val="000000"/>
                           </a:solidFill>
                           <a:latin typeface="Arial"/>
                         </a:rPr>
-                        <a:t>4</a:t>
+                        <a:t>Checks and verification · verification status line</a:t>
                       </a:r>
                     </a:p>
                   </a:txBody>
@@ -7295,7 +7320,7 @@
                     <a:lstStyle/>
                     <a:p>
                       <a:r>
-                        <a:rPr sz="1800" b="0">
+                        <a:rPr sz="1400" b="0">
                           <a:solidFill>
                             <a:srgbClr val="000000"/>
                           </a:solidFill>
@@ -7312,14 +7337,36 @@
                   </a:tcPr>
                 </a:tc>
               </a:tr>
-              <a:tr h="685800">
+              <a:tr h="868679">
                 <a:tc>
                   <a:txBody>
                     <a:bodyPr wrap="square"/>
                     <a:lstStyle/>
                     <a:p>
                       <a:r>
-                        <a:rPr sz="1800" b="0">
+                        <a:rPr sz="1400" b="0">
+                          <a:solidFill>
+                            <a:srgbClr val="000000"/>
+                          </a:solidFill>
+                          <a:latin typeface="Arial"/>
+                        </a:rPr>
+                        <a:t>5. Results &amp; figure honesty (15)</a:t>
+                      </a:r>
+                    </a:p>
+                  </a:txBody>
+                  <a:tcPr marL="73152" marR="73152" marT="27432" marB="27432">
+                    <a:solidFill>
+                      <a:srgbClr val="FFFFFF"/>
+                    </a:solidFill>
+                  </a:tcPr>
+                </a:tc>
+                <a:tc>
+                  <a:txBody>
+                    <a:bodyPr wrap="square"/>
+                    <a:lstStyle/>
+                    <a:p>
+                      <a:r>
+                        <a:rPr sz="1400" b="0">
                           <a:solidFill>
                             <a:srgbClr val="000000"/>
                           </a:solidFill>
@@ -7341,29 +7388,7 @@
                     <a:lstStyle/>
                     <a:p>
                       <a:r>
-                        <a:rPr sz="1800" b="0">
-                          <a:solidFill>
-                            <a:srgbClr val="000000"/>
-                          </a:solidFill>
-                          <a:latin typeface="Arial"/>
-                        </a:rPr>
-                        <a:t>5</a:t>
-                      </a:r>
-                    </a:p>
-                  </a:txBody>
-                  <a:tcPr marL="73152" marR="73152" marT="27432" marB="27432">
-                    <a:solidFill>
-                      <a:srgbClr val="FFFFFF"/>
-                    </a:solidFill>
-                  </a:tcPr>
-                </a:tc>
-                <a:tc>
-                  <a:txBody>
-                    <a:bodyPr wrap="square"/>
-                    <a:lstStyle/>
-                    <a:p>
-                      <a:r>
-                        <a:rPr sz="1800" b="0">
+                        <a:rPr sz="1400" b="0">
                           <a:solidFill>
                             <a:srgbClr val="000000"/>
                           </a:solidFill>
@@ -7380,14 +7405,36 @@
                   </a:tcPr>
                 </a:tc>
               </a:tr>
-              <a:tr h="685800">
+              <a:tr h="868679">
                 <a:tc>
                   <a:txBody>
                     <a:bodyPr wrap="square"/>
                     <a:lstStyle/>
                     <a:p>
                       <a:r>
-                        <a:rPr sz="1800" b="0">
+                        <a:rPr sz="1400" b="0">
+                          <a:solidFill>
+                            <a:srgbClr val="000000"/>
+                          </a:solidFill>
+                          <a:latin typeface="Arial"/>
+                        </a:rPr>
+                        <a:t>6. Interpretation, uncertainty &amp; limitations (15)</a:t>
+                      </a:r>
+                    </a:p>
+                  </a:txBody>
+                  <a:tcPr marL="73152" marR="73152" marT="27432" marB="27432">
+                    <a:solidFill>
+                      <a:srgbClr val="FFFFFF"/>
+                    </a:solidFill>
+                  </a:tcPr>
+                </a:tc>
+                <a:tc>
+                  <a:txBody>
+                    <a:bodyPr wrap="square"/>
+                    <a:lstStyle/>
+                    <a:p>
+                      <a:r>
+                        <a:rPr sz="1400" b="0">
                           <a:solidFill>
                             <a:srgbClr val="000000"/>
                           </a:solidFill>
@@ -7409,29 +7456,7 @@
                     <a:lstStyle/>
                     <a:p>
                       <a:r>
-                        <a:rPr sz="1800" b="0">
-                          <a:solidFill>
-                            <a:srgbClr val="000000"/>
-                          </a:solidFill>
-                          <a:latin typeface="Arial"/>
-                        </a:rPr>
-                        <a:t>6</a:t>
-                      </a:r>
-                    </a:p>
-                  </a:txBody>
-                  <a:tcPr marL="73152" marR="73152" marT="27432" marB="27432">
-                    <a:solidFill>
-                      <a:srgbClr val="FFFFFF"/>
-                    </a:solidFill>
-                  </a:tcPr>
-                </a:tc>
-                <a:tc>
-                  <a:txBody>
-                    <a:bodyPr wrap="square"/>
-                    <a:lstStyle/>
-                    <a:p>
-                      <a:r>
-                        <a:rPr sz="1800" b="0">
+                        <a:rPr sz="1400" b="0">
                           <a:solidFill>
                             <a:srgbClr val="000000"/>
                           </a:solidFill>
@@ -7448,14 +7473,36 @@
                   </a:tcPr>
                 </a:tc>
               </a:tr>
-              <a:tr h="685800">
+              <a:tr h="868679">
                 <a:tc>
                   <a:txBody>
                     <a:bodyPr wrap="square"/>
                     <a:lstStyle/>
                     <a:p>
                       <a:r>
-                        <a:rPr sz="1800" b="0">
+                        <a:rPr sz="1400" b="0">
+                          <a:solidFill>
+                            <a:srgbClr val="000000"/>
+                          </a:solidFill>
+                          <a:latin typeface="Arial"/>
+                        </a:rPr>
+                        <a:t>7. Sources, AI disclosure &amp; credit (8)</a:t>
+                      </a:r>
+                    </a:p>
+                  </a:txBody>
+                  <a:tcPr marL="73152" marR="73152" marT="27432" marB="27432">
+                    <a:solidFill>
+                      <a:srgbClr val="FFFFFF"/>
+                    </a:solidFill>
+                  </a:tcPr>
+                </a:tc>
+                <a:tc>
+                  <a:txBody>
+                    <a:bodyPr wrap="square"/>
+                    <a:lstStyle/>
+                    <a:p>
+                      <a:r>
+                        <a:rPr sz="1400" b="0">
                           <a:solidFill>
                             <a:srgbClr val="000000"/>
                           </a:solidFill>
@@ -7477,29 +7524,7 @@
                     <a:lstStyle/>
                     <a:p>
                       <a:r>
-                        <a:rPr sz="1800" b="0">
-                          <a:solidFill>
-                            <a:srgbClr val="000000"/>
-                          </a:solidFill>
-                          <a:latin typeface="Arial"/>
-                        </a:rPr>
-                        <a:t>7</a:t>
-                      </a:r>
-                    </a:p>
-                  </a:txBody>
-                  <a:tcPr marL="73152" marR="73152" marT="27432" marB="27432">
-                    <a:solidFill>
-                      <a:srgbClr val="FFFFFF"/>
-                    </a:solidFill>
-                  </a:tcPr>
-                </a:tc>
-                <a:tc>
-                  <a:txBody>
-                    <a:bodyPr wrap="square"/>
-                    <a:lstStyle/>
-                    <a:p>
-                      <a:r>
-                        <a:rPr sz="1800" b="0">
+                        <a:rPr sz="1400" b="0">
                           <a:solidFill>
                             <a:srgbClr val="000000"/>
                           </a:solidFill>
@@ -7516,14 +7541,36 @@
                   </a:tcPr>
                 </a:tc>
               </a:tr>
-              <a:tr h="685800">
+              <a:tr h="868687">
                 <a:tc>
                   <a:txBody>
                     <a:bodyPr wrap="square"/>
                     <a:lstStyle/>
                     <a:p>
                       <a:r>
-                        <a:rPr sz="1800" b="0">
+                        <a:rPr sz="1400" b="0">
+                          <a:solidFill>
+                            <a:srgbClr val="000000"/>
+                          </a:solidFill>
+                          <a:latin typeface="Arial"/>
+                        </a:rPr>
+                        <a:t>8. Visual communication &amp; accessibility (10)</a:t>
+                      </a:r>
+                    </a:p>
+                  </a:txBody>
+                  <a:tcPr marL="73152" marR="73152" marT="27432" marB="27432">
+                    <a:solidFill>
+                      <a:srgbClr val="FFFFFF"/>
+                    </a:solidFill>
+                  </a:tcPr>
+                </a:tc>
+                <a:tc>
+                  <a:txBody>
+                    <a:bodyPr wrap="square"/>
+                    <a:lstStyle/>
+                    <a:p>
+                      <a:r>
+                        <a:rPr sz="1400" b="0">
                           <a:solidFill>
                             <a:srgbClr val="000000"/>
                           </a:solidFill>
@@ -7545,29 +7592,7 @@
                     <a:lstStyle/>
                     <a:p>
                       <a:r>
-                        <a:rPr sz="1800" b="0">
-                          <a:solidFill>
-                            <a:srgbClr val="000000"/>
-                          </a:solidFill>
-                          <a:latin typeface="Arial"/>
-                        </a:rPr>
-                        <a:t>8</a:t>
-                      </a:r>
-                    </a:p>
-                  </a:txBody>
-                  <a:tcPr marL="73152" marR="73152" marT="27432" marB="27432">
-                    <a:solidFill>
-                      <a:srgbClr val="FFFFFF"/>
-                    </a:solidFill>
-                  </a:tcPr>
-                </a:tc>
-                <a:tc>
-                  <a:txBody>
-                    <a:bodyPr wrap="square"/>
-                    <a:lstStyle/>
-                    <a:p>
-                      <a:r>
-                        <a:rPr sz="1800" b="0">
+                        <a:rPr sz="1400" b="0">
                           <a:solidFill>
                             <a:srgbClr val="000000"/>
                           </a:solidFill>
@@ -7596,7 +7621,7 @@
         </p:nvSpPr>
         <p:spPr>
           <a:xfrm>
-            <a:off x="20939760" y="10515600"/>
+            <a:off x="20939760" y="11887200"/>
             <a:ext cx="9692640" cy="3657600"/>
           </a:xfrm>
           <a:prstGeom prst="rect">
@@ -7622,7 +7647,7 @@
                 </a:solidFill>
                 <a:latin typeface="Arial"/>
               </a:rPr>
-              <a:t>The final poster (M13) is graded with Evidence_Driven_Research_Poster_Rubric.pdf: eight criteria, 100 points, hard caps. Read it before you build.</a:t>
+              <a:t>The final poster (M13) is graded with Evidence_Driven_Research_Poster_Rubric.pdf: eight criteria, 100 points, hard caps. Read it before you build, and check your board against it before M10 and M11.</a:t>
             </a:r>
           </a:p>
         </p:txBody>

</xml_diff>